<commit_message>
docs: refine presentation layout and freemium model
Co-authored-by: arena-agent <297053741+arena-agent@users.noreply.github.com>
</commit_message>
<xml_diff>
--- a/presentation/MindMate_Competition_Presentation.pptx
+++ b/presentation/MindMate_Competition_Presentation.pptx
@@ -687,7 +687,7 @@
           <a:p>
             <a:r>
               <a:rPr lang="en-US" dirty="0"/>
-              <a:t>The problem is the gap between needing help and knowing what to do next. Many people struggle to understand their emotions, feel overwhelmed by too many options, and do not know where to find the right support. Add a verified source for the headline statistic before final submission.</a:t>
+              <a:t>The problem is the gap between needing help and knowing what to do next. The headline statistic must have a verified source before final submission.</a:t>
             </a:r>
             <a:endParaRPr lang="en-US" dirty="0"/>
           </a:p>
@@ -775,7 +775,7 @@
           <a:p>
             <a:r>
               <a:rPr lang="en-US" dirty="0"/>
-              <a:t>MindMate connects awareness, action, conversation, and human support. It is a guided pathway rather than a collection of unrelated features.</a:t>
+              <a:t>MindMate helps users check in, reflect, act, and connect. It is a guided pathway rather than a collection of unrelated features.</a:t>
             </a:r>
             <a:endParaRPr lang="en-US" dirty="0"/>
           </a:p>
@@ -863,7 +863,7 @@
           <a:p>
             <a:r>
               <a:rPr lang="en-US" dirty="0"/>
-              <a:t>Explain that MindMate supports reflection and practical next steps, but does not replace professional care. When risk appears, it provides a clear route to Emergency Support.</a:t>
+              <a:t>MindMate supports reflection and practical next steps, but does not replace professional care. When risk appears, it points the user to Emergency Support.</a:t>
             </a:r>
             <a:endParaRPr lang="en-US" dirty="0"/>
           </a:p>
@@ -951,7 +951,7 @@
           <a:p>
             <a:r>
               <a:rPr lang="en-US" dirty="0"/>
-              <a:t>Keep this generic. We are explaining MindMate’s integrated journey without making unsupported claims about named competitors.</a:t>
+              <a:t>This slide explains MindMate’s integrated journey without making unsupported claims about named competitors.</a:t>
             </a:r>
             <a:endParaRPr lang="en-US" dirty="0"/>
           </a:p>
@@ -1039,7 +1039,7 @@
           <a:p>
             <a:r>
               <a:rPr lang="en-US" dirty="0"/>
-              <a:t>Explain the product readiness in plain language: an installable Android release, a live Web release, and testing of the core user journeys. Do not lead with programming terminology.</a:t>
+              <a:t>Explain product readiness in plain language: an installable Android build, a live Web release, and tested core journeys.</a:t>
             </a:r>
             <a:endParaRPr lang="en-US" dirty="0"/>
           </a:p>
@@ -1127,7 +1127,7 @@
           <a:p>
             <a:r>
               <a:rPr lang="en-US" dirty="0"/>
-              <a:t>This is a future revenue strategy, not current revenue. Do not claim paying customers, active subscriptions, sponsors, or organisation contracts. The free core remains accessible and future depth must be validated responsibly.</a:t>
+              <a:t>The freemium unlock is simulated for the demo; no real payment is processed. The ₦10,000 annual price and 500 paid users are an illustrative future scenario, not current revenue. The team should validate the price, conversion rate, and paid features before presenting them as a final business plan.</a:t>
             </a:r>
             <a:endParaRPr lang="en-US" dirty="0"/>
           </a:p>
@@ -1215,7 +1215,7 @@
           <a:p>
             <a:r>
               <a:rPr lang="en-US" dirty="0"/>
-              <a:t>This slide preserves the captain’s financial table while clarifying that the figures must be labelled illustrative or projected unless the team has verified records. Replace or correct any figure that is not supported.</a:t>
+              <a:t>This slide shows the full revenue calculation: shares are ₦500 times 100, sponsorship is one sponsor at ₦200,000, and confectioneries are ₦100 times 500. The total is ₦300,000. Treat it as projected until the records are verified.</a:t>
             </a:r>
             <a:endParaRPr lang="en-US" dirty="0"/>
           </a:p>
@@ -2769,25 +2769,66 @@
         <p:spPr>
           <a:xfrm>
             <a:off x="621792" y="384048"/>
-            <a:ext cx="10972800" cy="411480"/>
-          </a:xfrm>
-          <a:prstGeom prst="rect">
-            <a:avLst/>
-          </a:prstGeom>
-          <a:noFill/>
-          <a:ln/>
-        </p:spPr>
-        <p:txBody>
-          <a:bodyPr wrap="square" lIns="0" tIns="0" rIns="0" bIns="0" rtlCol="0" anchor="ctr">
-            <a:normAutofit/>
-          </a:bodyPr>
-          <a:lstStyle/>
-          <a:p>
-            <a:pPr algn="ctr" indent="0" marL="0">
-              <a:buNone/>
-            </a:pPr>
-            <a:r>
-              <a:rPr lang="en-US" sz="2700" b="1" dirty="0">
+            <a:ext cx="5303520" cy="219456"/>
+          </a:xfrm>
+          <a:prstGeom prst="rect">
+            <a:avLst/>
+          </a:prstGeom>
+          <a:noFill/>
+          <a:ln/>
+        </p:spPr>
+        <p:txBody>
+          <a:bodyPr wrap="square" lIns="0" tIns="0" rIns="0" bIns="0" rtlCol="0" anchor="ctr">
+            <a:normAutofit/>
+          </a:bodyPr>
+          <a:lstStyle/>
+          <a:p>
+            <a:pPr algn="l" indent="0" marL="0">
+              <a:buNone/>
+            </a:pPr>
+            <a:r>
+              <a:rPr lang="en-US" sz="1000" b="1" spc="140" kern="0" dirty="0">
+                <a:solidFill>
+                  <a:srgbClr val="2E7D73"/>
+                </a:solidFill>
+                <a:latin typeface="Arial" pitchFamily="34" charset="0"/>
+                <a:ea typeface="Arial" pitchFamily="34" charset="-122"/>
+                <a:cs typeface="Arial" pitchFamily="34" charset="-120"/>
+              </a:rPr>
+              <a:t>PROBLEM STATEMENT</a:t>
+            </a:r>
+            <a:endParaRPr lang="en-US" sz="1000" dirty="0"/>
+          </a:p>
+        </p:txBody>
+      </p:sp>
+      <p:sp>
+        <p:nvSpPr>
+          <p:cNvPr id="3" name="Text 1"/>
+          <p:cNvSpPr/>
+          <p:nvPr/>
+        </p:nvSpPr>
+        <p:spPr>
+          <a:xfrm>
+            <a:off x="621792" y="658368"/>
+            <a:ext cx="10972800" cy="676656"/>
+          </a:xfrm>
+          <a:prstGeom prst="rect">
+            <a:avLst/>
+          </a:prstGeom>
+          <a:noFill/>
+          <a:ln/>
+        </p:spPr>
+        <p:txBody>
+          <a:bodyPr wrap="square" lIns="0" tIns="0" rIns="0" bIns="0" rtlCol="0" anchor="ctr">
+            <a:normAutofit/>
+          </a:bodyPr>
+          <a:lstStyle/>
+          <a:p>
+            <a:pPr algn="l" indent="0" marL="0">
+              <a:buNone/>
+            </a:pPr>
+            <a:r>
+              <a:rPr lang="en-US" sz="2800" b="1" dirty="0">
                 <a:solidFill>
                   <a:srgbClr val="12232B"/>
                 </a:solidFill>
@@ -2795,84 +2836,67 @@
                 <a:ea typeface="Arial" pitchFamily="34" charset="-122"/>
                 <a:cs typeface="Arial" pitchFamily="34" charset="-120"/>
               </a:rPr>
-              <a:t>PROBLEM STATEMENT</a:t>
-            </a:r>
-            <a:endParaRPr lang="en-US" sz="2700" dirty="0"/>
-          </a:p>
-        </p:txBody>
-      </p:sp>
-      <p:sp>
-        <p:nvSpPr>
-          <p:cNvPr id="3" name="Text 1"/>
-          <p:cNvSpPr/>
-          <p:nvPr/>
-        </p:nvSpPr>
-        <p:spPr>
-          <a:xfrm>
-            <a:off x="822960" y="896112"/>
-            <a:ext cx="10561320" cy="566928"/>
-          </a:xfrm>
-          <a:prstGeom prst="rect">
-            <a:avLst/>
-          </a:prstGeom>
-          <a:noFill/>
-          <a:ln/>
-        </p:spPr>
-        <p:txBody>
-          <a:bodyPr wrap="square" lIns="0" tIns="0" rIns="0" bIns="0" rtlCol="0" anchor="ctr">
-            <a:normAutofit/>
-          </a:bodyPr>
-          <a:lstStyle/>
-          <a:p>
-            <a:pPr algn="ctr" indent="0" marL="0">
-              <a:buNone/>
-            </a:pPr>
-            <a:r>
-              <a:rPr lang="en-US" sz="1500" b="1" dirty="0">
-                <a:solidFill>
-                  <a:srgbClr val="12232B"/>
-                </a:solidFill>
-                <a:latin typeface="Arial" pitchFamily="34" charset="0"/>
-                <a:ea typeface="Arial" pitchFamily="34" charset="-122"/>
-                <a:cs typeface="Arial" pitchFamily="34" charset="-120"/>
-              </a:rPr>
-              <a:t>NEARLY 150 MILLION PEOPLE IN AFRICA ALONE SUFFER FROM MENTAL</a:t>
-            </a:r>
-            <a:endParaRPr lang="en-US" sz="1500" dirty="0"/>
-          </a:p>
-          <a:p>
-            <a:pPr algn="ctr" indent="0" marL="0">
-              <a:buNone/>
-            </a:pPr>
-            <a:r>
-              <a:rPr lang="en-US" sz="1500" b="1" dirty="0">
-                <a:solidFill>
-                  <a:srgbClr val="12232B"/>
-                </a:solidFill>
-                <a:latin typeface="Arial" pitchFamily="34" charset="0"/>
-                <a:ea typeface="Arial" pitchFamily="34" charset="-122"/>
-                <a:cs typeface="Arial" pitchFamily="34" charset="-120"/>
-              </a:rPr>
-              <a:t>HEALTH ISSUES, INCLUDING ABOUT 105 MILLION IN NIGERIA ALONE</a:t>
-            </a:r>
-            <a:endParaRPr lang="en-US" sz="1500" dirty="0"/>
-          </a:p>
-        </p:txBody>
-      </p:sp>
-      <p:sp>
-        <p:nvSpPr>
-          <p:cNvPr id="4" name="Shape 2"/>
-          <p:cNvSpPr/>
-          <p:nvPr/>
-        </p:nvSpPr>
-        <p:spPr>
-          <a:xfrm>
-            <a:off x="658368" y="2148840"/>
-            <a:ext cx="3401568" cy="2852928"/>
+              <a:t>Many people need help before they know where to start</a:t>
+            </a:r>
+            <a:endParaRPr lang="en-US" sz="2800" dirty="0"/>
+          </a:p>
+        </p:txBody>
+      </p:sp>
+      <p:sp>
+        <p:nvSpPr>
+          <p:cNvPr id="4" name="Text 2"/>
+          <p:cNvSpPr/>
+          <p:nvPr/>
+        </p:nvSpPr>
+        <p:spPr>
+          <a:xfrm>
+            <a:off x="640080" y="1399032"/>
+            <a:ext cx="10607040" cy="347472"/>
+          </a:xfrm>
+          <a:prstGeom prst="rect">
+            <a:avLst/>
+          </a:prstGeom>
+          <a:noFill/>
+          <a:ln/>
+        </p:spPr>
+        <p:txBody>
+          <a:bodyPr wrap="square" lIns="0" tIns="0" rIns="0" bIns="0" rtlCol="0" anchor="ctr">
+            <a:normAutofit/>
+          </a:bodyPr>
+          <a:lstStyle/>
+          <a:p>
+            <a:pPr algn="l" indent="0" marL="0">
+              <a:buNone/>
+            </a:pPr>
+            <a:r>
+              <a:rPr lang="en-US" sz="1300" dirty="0">
+                <a:solidFill>
+                  <a:srgbClr val="68767C"/>
+                </a:solidFill>
+                <a:latin typeface="Arial" pitchFamily="34" charset="0"/>
+                <a:ea typeface="Arial" pitchFamily="34" charset="-122"/>
+                <a:cs typeface="Arial" pitchFamily="34" charset="-120"/>
+              </a:rPr>
+              <a:t>Nearly 150 million people in Africa — including about 105 million in Nigeria — are reported to face mental-health challenges. Verify this statistic before submission.</a:t>
+            </a:r>
+            <a:endParaRPr lang="en-US" sz="1300" dirty="0"/>
+          </a:p>
+        </p:txBody>
+      </p:sp>
+      <p:sp>
+        <p:nvSpPr>
+          <p:cNvPr id="5" name="Shape 3"/>
+          <p:cNvSpPr/>
+          <p:nvPr/>
+        </p:nvSpPr>
+        <p:spPr>
+          <a:xfrm>
+            <a:off x="658368" y="2057400"/>
+            <a:ext cx="3401568" cy="2944368"/>
           </a:xfrm>
           <a:prstGeom prst="roundRect">
             <a:avLst>
-              <a:gd name="adj" fmla="val 2564"/>
+              <a:gd name="adj" fmla="val 2484"/>
             </a:avLst>
           </a:prstGeom>
           <a:solidFill>
@@ -2890,13 +2914,13 @@
       </p:sp>
       <p:sp>
         <p:nvSpPr>
-          <p:cNvPr id="5" name="Text 3"/>
-          <p:cNvSpPr/>
-          <p:nvPr/>
-        </p:nvSpPr>
-        <p:spPr>
-          <a:xfrm>
-            <a:off x="877824" y="2350008"/>
+          <p:cNvPr id="6" name="Text 4"/>
+          <p:cNvSpPr/>
+          <p:nvPr/>
+        </p:nvSpPr>
+        <p:spPr>
+          <a:xfrm>
+            <a:off x="877824" y="2258568"/>
             <a:ext cx="2962656" cy="310896"/>
           </a:xfrm>
           <a:prstGeom prst="rect">
@@ -2923,39 +2947,22 @@
                 <a:ea typeface="Arial" pitchFamily="34" charset="-122"/>
                 <a:cs typeface="Arial" pitchFamily="34" charset="-120"/>
               </a:rPr>
-              <a:t>DIFFICULTY WITH EMOTIONAL</a:t>
+              <a:t>HARD TO NAME IT</a:t>
             </a:r>
             <a:endParaRPr lang="en-US" sz="1350" dirty="0"/>
           </a:p>
-          <a:p>
-            <a:pPr algn="l" indent="0" marL="0">
-              <a:buNone/>
-            </a:pPr>
-            <a:r>
-              <a:rPr lang="en-US" sz="1350" b="1" spc="60" kern="0" dirty="0">
-                <a:solidFill>
-                  <a:srgbClr val="2E7D73"/>
-                </a:solidFill>
-                <a:latin typeface="Arial" pitchFamily="34" charset="0"/>
-                <a:ea typeface="Arial" pitchFamily="34" charset="-122"/>
-                <a:cs typeface="Arial" pitchFamily="34" charset="-120"/>
-              </a:rPr>
-              <a:t>AWARENESS</a:t>
-            </a:r>
-            <a:endParaRPr lang="en-US" sz="1350" dirty="0"/>
-          </a:p>
-        </p:txBody>
-      </p:sp>
-      <p:sp>
-        <p:nvSpPr>
-          <p:cNvPr id="6" name="Text 4"/>
-          <p:cNvSpPr/>
-          <p:nvPr/>
-        </p:nvSpPr>
-        <p:spPr>
-          <a:xfrm>
-            <a:off x="877824" y="2834640"/>
-            <a:ext cx="2962656" cy="1682496"/>
+        </p:txBody>
+      </p:sp>
+      <p:sp>
+        <p:nvSpPr>
+          <p:cNvPr id="7" name="Text 5"/>
+          <p:cNvSpPr/>
+          <p:nvPr/>
+        </p:nvSpPr>
+        <p:spPr>
+          <a:xfrm>
+            <a:off x="877824" y="2743200"/>
+            <a:ext cx="2962656" cy="1773936"/>
           </a:xfrm>
           <a:prstGeom prst="rect">
             <a:avLst/>
@@ -2981,7 +2988,7 @@
                 <a:ea typeface="Arial" pitchFamily="34" charset="-122"/>
                 <a:cs typeface="Arial" pitchFamily="34" charset="-120"/>
               </a:rPr>
-              <a:t>Without a simple way to check in, people may struggle to understand what is affecting their mood or recognise patterns over time.</a:t>
+              <a:t>People may feel bad without knowing what is affecting them.</a:t>
             </a:r>
             <a:endParaRPr lang="en-US" sz="1300" dirty="0"/>
           </a:p>
@@ -2989,7 +2996,7 @@
       </p:sp>
       <p:sp>
         <p:nvSpPr>
-          <p:cNvPr id="7" name="Text 5"/>
+          <p:cNvPr id="8" name="Text 6"/>
           <p:cNvSpPr/>
           <p:nvPr/>
         </p:nvSpPr>
@@ -3022,7 +3029,7 @@
                 <a:ea typeface="Arial" pitchFamily="34" charset="-122"/>
                 <a:cs typeface="Arial" pitchFamily="34" charset="-120"/>
               </a:rPr>
-              <a:t>Check in + reflect</a:t>
+              <a:t>Start with awareness</a:t>
             </a:r>
             <a:endParaRPr lang="en-US" sz="1050" dirty="0"/>
           </a:p>
@@ -3030,18 +3037,18 @@
       </p:sp>
       <p:sp>
         <p:nvSpPr>
-          <p:cNvPr id="8" name="Shape 6"/>
-          <p:cNvSpPr/>
-          <p:nvPr/>
-        </p:nvSpPr>
-        <p:spPr>
-          <a:xfrm>
-            <a:off x="4425696" y="2148840"/>
-            <a:ext cx="3401568" cy="2852928"/>
+          <p:cNvPr id="9" name="Shape 7"/>
+          <p:cNvSpPr/>
+          <p:nvPr/>
+        </p:nvSpPr>
+        <p:spPr>
+          <a:xfrm>
+            <a:off x="4425696" y="2057400"/>
+            <a:ext cx="3401568" cy="2944368"/>
           </a:xfrm>
           <a:prstGeom prst="roundRect">
             <a:avLst>
-              <a:gd name="adj" fmla="val 2564"/>
+              <a:gd name="adj" fmla="val 2484"/>
             </a:avLst>
           </a:prstGeom>
           <a:solidFill>
@@ -3059,13 +3066,13 @@
       </p:sp>
       <p:sp>
         <p:nvSpPr>
-          <p:cNvPr id="9" name="Text 7"/>
-          <p:cNvSpPr/>
-          <p:nvPr/>
-        </p:nvSpPr>
-        <p:spPr>
-          <a:xfrm>
-            <a:off x="4645152" y="2350008"/>
+          <p:cNvPr id="10" name="Text 8"/>
+          <p:cNvSpPr/>
+          <p:nvPr/>
+        </p:nvSpPr>
+        <p:spPr>
+          <a:xfrm>
+            <a:off x="4645152" y="2258568"/>
             <a:ext cx="2962656" cy="310896"/>
           </a:xfrm>
           <a:prstGeom prst="rect">
@@ -3092,39 +3099,22 @@
                 <a:ea typeface="Arial" pitchFamily="34" charset="-122"/>
                 <a:cs typeface="Arial" pitchFamily="34" charset="-120"/>
               </a:rPr>
-              <a:t>TOO MANY OPTIONS, NO</a:t>
+              <a:t>HARD TO KNOW WHAT TO DO</a:t>
             </a:r>
             <a:endParaRPr lang="en-US" sz="1350" dirty="0"/>
           </a:p>
-          <a:p>
-            <a:pPr algn="l" indent="0" marL="0">
-              <a:buNone/>
-            </a:pPr>
-            <a:r>
-              <a:rPr lang="en-US" sz="1350" b="1" spc="60" kern="0" dirty="0">
-                <a:solidFill>
-                  <a:srgbClr val="2E7D73"/>
-                </a:solidFill>
-                <a:latin typeface="Arial" pitchFamily="34" charset="0"/>
-                <a:ea typeface="Arial" pitchFamily="34" charset="-122"/>
-                <a:cs typeface="Arial" pitchFamily="34" charset="-120"/>
-              </a:rPr>
-              <a:t>CLEAR FIRST STEP</a:t>
-            </a:r>
-            <a:endParaRPr lang="en-US" sz="1350" dirty="0"/>
-          </a:p>
-        </p:txBody>
-      </p:sp>
-      <p:sp>
-        <p:nvSpPr>
-          <p:cNvPr id="10" name="Text 8"/>
-          <p:cNvSpPr/>
-          <p:nvPr/>
-        </p:nvSpPr>
-        <p:spPr>
-          <a:xfrm>
-            <a:off x="4645152" y="2834640"/>
-            <a:ext cx="2962656" cy="1682496"/>
+        </p:txBody>
+      </p:sp>
+      <p:sp>
+        <p:nvSpPr>
+          <p:cNvPr id="11" name="Text 9"/>
+          <p:cNvSpPr/>
+          <p:nvPr/>
+        </p:nvSpPr>
+        <p:spPr>
+          <a:xfrm>
+            <a:off x="4645152" y="2743200"/>
+            <a:ext cx="2962656" cy="1773936"/>
           </a:xfrm>
           <a:prstGeom prst="rect">
             <a:avLst/>
@@ -3150,7 +3140,7 @@
                 <a:ea typeface="Arial" pitchFamily="34" charset="-122"/>
                 <a:cs typeface="Arial" pitchFamily="34" charset="-120"/>
               </a:rPr>
-              <a:t>When people are overwhelmed, too many options can make it harder to know where to begin.</a:t>
+              <a:t>Too many options can make the first step harder.</a:t>
             </a:r>
             <a:endParaRPr lang="en-US" sz="1300" dirty="0"/>
           </a:p>
@@ -3158,7 +3148,7 @@
       </p:sp>
       <p:sp>
         <p:nvSpPr>
-          <p:cNvPr id="11" name="Text 9"/>
+          <p:cNvPr id="12" name="Text 10"/>
           <p:cNvSpPr/>
           <p:nvPr/>
         </p:nvSpPr>
@@ -3191,7 +3181,7 @@
                 <a:ea typeface="Arial" pitchFamily="34" charset="-122"/>
                 <a:cs typeface="Arial" pitchFamily="34" charset="-120"/>
               </a:rPr>
-              <a:t>Personalised next step</a:t>
+              <a:t>Make one small move</a:t>
             </a:r>
             <a:endParaRPr lang="en-US" sz="1050" dirty="0"/>
           </a:p>
@@ -3199,18 +3189,18 @@
       </p:sp>
       <p:sp>
         <p:nvSpPr>
-          <p:cNvPr id="12" name="Shape 10"/>
-          <p:cNvSpPr/>
-          <p:nvPr/>
-        </p:nvSpPr>
-        <p:spPr>
-          <a:xfrm>
-            <a:off x="8193024" y="2148840"/>
-            <a:ext cx="3401568" cy="2852928"/>
+          <p:cNvPr id="13" name="Shape 11"/>
+          <p:cNvSpPr/>
+          <p:nvPr/>
+        </p:nvSpPr>
+        <p:spPr>
+          <a:xfrm>
+            <a:off x="8193024" y="2057400"/>
+            <a:ext cx="3401568" cy="2944368"/>
           </a:xfrm>
           <a:prstGeom prst="roundRect">
             <a:avLst>
-              <a:gd name="adj" fmla="val 2564"/>
+              <a:gd name="adj" fmla="val 2484"/>
             </a:avLst>
           </a:prstGeom>
           <a:solidFill>
@@ -3228,13 +3218,13 @@
       </p:sp>
       <p:sp>
         <p:nvSpPr>
-          <p:cNvPr id="13" name="Text 11"/>
-          <p:cNvSpPr/>
-          <p:nvPr/>
-        </p:nvSpPr>
-        <p:spPr>
-          <a:xfrm>
-            <a:off x="8412480" y="2350008"/>
+          <p:cNvPr id="14" name="Text 12"/>
+          <p:cNvSpPr/>
+          <p:nvPr/>
+        </p:nvSpPr>
+        <p:spPr>
+          <a:xfrm>
+            <a:off x="8412480" y="2258568"/>
             <a:ext cx="2962656" cy="310896"/>
           </a:xfrm>
           <a:prstGeom prst="rect">
@@ -3261,39 +3251,22 @@
                 <a:ea typeface="Arial" pitchFamily="34" charset="-122"/>
                 <a:cs typeface="Arial" pitchFamily="34" charset="-120"/>
               </a:rPr>
-              <a:t>DIFFICULTY FINDING THE</a:t>
+              <a:t>HARD TO FIND SUPPORT</a:t>
             </a:r>
             <a:endParaRPr lang="en-US" sz="1350" dirty="0"/>
           </a:p>
-          <a:p>
-            <a:pPr algn="l" indent="0" marL="0">
-              <a:buNone/>
-            </a:pPr>
-            <a:r>
-              <a:rPr lang="en-US" sz="1350" b="1" spc="60" kern="0" dirty="0">
-                <a:solidFill>
-                  <a:srgbClr val="78AFA2"/>
-                </a:solidFill>
-                <a:latin typeface="Arial" pitchFamily="34" charset="0"/>
-                <a:ea typeface="Arial" pitchFamily="34" charset="-122"/>
-                <a:cs typeface="Arial" pitchFamily="34" charset="-120"/>
-              </a:rPr>
-              <a:t>RIGHT SUPPORT</a:t>
-            </a:r>
-            <a:endParaRPr lang="en-US" sz="1350" dirty="0"/>
-          </a:p>
-        </p:txBody>
-      </p:sp>
-      <p:sp>
-        <p:nvSpPr>
-          <p:cNvPr id="14" name="Text 12"/>
-          <p:cNvSpPr/>
-          <p:nvPr/>
-        </p:nvSpPr>
-        <p:spPr>
-          <a:xfrm>
-            <a:off x="8412480" y="2834640"/>
-            <a:ext cx="2962656" cy="1682496"/>
+        </p:txBody>
+      </p:sp>
+      <p:sp>
+        <p:nvSpPr>
+          <p:cNvPr id="15" name="Text 13"/>
+          <p:cNvSpPr/>
+          <p:nvPr/>
+        </p:nvSpPr>
+        <p:spPr>
+          <a:xfrm>
+            <a:off x="8412480" y="2743200"/>
+            <a:ext cx="2962656" cy="1773936"/>
           </a:xfrm>
           <a:prstGeom prst="rect">
             <a:avLst/>
@@ -3319,7 +3292,7 @@
                 <a:ea typeface="Arial" pitchFamily="34" charset="-122"/>
                 <a:cs typeface="Arial" pitchFamily="34" charset="-120"/>
               </a:rPr>
-              <a:t>When self-guided support is not enough, knowing who to contact can be difficult in the moment.</a:t>
+              <a:t>When self-guided help is not enough, the right person can be hard to find.</a:t>
             </a:r>
             <a:endParaRPr lang="en-US" sz="1300" dirty="0"/>
           </a:p>
@@ -3327,7 +3300,7 @@
       </p:sp>
       <p:sp>
         <p:nvSpPr>
-          <p:cNvPr id="15" name="Text 13"/>
+          <p:cNvPr id="16" name="Text 14"/>
           <p:cNvSpPr/>
           <p:nvPr/>
         </p:nvSpPr>
@@ -3360,7 +3333,7 @@
                 <a:ea typeface="Arial" pitchFamily="34" charset="-122"/>
                 <a:cs typeface="Arial" pitchFamily="34" charset="-120"/>
               </a:rPr>
-              <a:t>Connect to human support</a:t>
+              <a:t>Know where to go next</a:t>
             </a:r>
             <a:endParaRPr lang="en-US" sz="1050" dirty="0"/>
           </a:p>
@@ -3368,7 +3341,7 @@
       </p:sp>
       <p:sp>
         <p:nvSpPr>
-          <p:cNvPr id="16" name="Shape 14"/>
+          <p:cNvPr id="17" name="Shape 15"/>
           <p:cNvSpPr/>
           <p:nvPr/>
         </p:nvSpPr>
@@ -3397,7 +3370,7 @@
       </p:sp>
       <p:sp>
         <p:nvSpPr>
-          <p:cNvPr id="17" name="Text 15"/>
+          <p:cNvPr id="18" name="Text 16"/>
           <p:cNvSpPr/>
           <p:nvPr/>
         </p:nvSpPr>
@@ -3430,7 +3403,7 @@
                 <a:ea typeface="Arial" pitchFamily="34" charset="-122"/>
                 <a:cs typeface="Arial" pitchFamily="34" charset="-120"/>
               </a:rPr>
-              <a:t>The problem is not a lack of information. It is the gap between “I need help” and “I know what to do next.”</a:t>
+              <a:t>MindMate closes the gap between “I need help” and “What do I do next?”</a:t>
             </a:r>
             <a:endParaRPr lang="en-US" sz="1200" dirty="0"/>
           </a:p>
@@ -3438,7 +3411,7 @@
       </p:sp>
       <p:sp>
         <p:nvSpPr>
-          <p:cNvPr id="18" name="Text 16"/>
+          <p:cNvPr id="19" name="Text 17"/>
           <p:cNvSpPr/>
           <p:nvPr/>
         </p:nvSpPr>
@@ -3626,7 +3599,7 @@
                 <a:ea typeface="Arial" pitchFamily="34" charset="-122"/>
                 <a:cs typeface="Arial" pitchFamily="34" charset="-120"/>
               </a:rPr>
-              <a:t>MindMate turns an overwhelming moment into one clear next step</a:t>
+              <a:t>From a difficult moment to one next step</a:t>
             </a:r>
             <a:endParaRPr lang="en-US" sz="2800" dirty="0"/>
           </a:p>
@@ -3667,7 +3640,7 @@
                 <a:ea typeface="Arial" pitchFamily="34" charset="-122"/>
                 <a:cs typeface="Arial" pitchFamily="34" charset="-120"/>
               </a:rPr>
-              <a:t>It connects emotional awareness, practical action, supportive conversation, and human support in one guided pathway.</a:t>
+              <a:t>MindMate helps users check in, reflect, act, and connect.</a:t>
             </a:r>
             <a:endParaRPr lang="en-US" sz="1300" dirty="0"/>
           </a:p>
@@ -3778,7 +3751,7 @@
                 <a:ea typeface="Arial" pitchFamily="34" charset="-122"/>
                 <a:cs typeface="Arial" pitchFamily="34" charset="-120"/>
               </a:rPr>
-              <a:t>Pause and understand what you are experiencing before deciding what to do.</a:t>
+              <a:t>Name what is happening before deciding what to do.</a:t>
             </a:r>
             <a:endParaRPr lang="en-US" sz="1300" dirty="0"/>
           </a:p>
@@ -3930,7 +3903,7 @@
                 <a:ea typeface="Arial" pitchFamily="34" charset="-122"/>
                 <a:cs typeface="Arial" pitchFamily="34" charset="-120"/>
               </a:rPr>
-              <a:t>Choose one manageable action, with alternatives if the first step does not help.</a:t>
+              <a:t>Choose one small action. If it does not help, try another.</a:t>
             </a:r>
             <a:endParaRPr lang="en-US" sz="1300" dirty="0"/>
           </a:p>
@@ -3971,7 +3944,7 @@
                 <a:ea typeface="Arial" pitchFamily="34" charset="-122"/>
                 <a:cs typeface="Arial" pitchFamily="34" charset="-120"/>
               </a:rPr>
-              <a:t>Start small. Try another way.</a:t>
+              <a:t>Start small</a:t>
             </a:r>
             <a:endParaRPr lang="en-US" sz="1050" dirty="0"/>
           </a:p>
@@ -4082,7 +4055,7 @@
                 <a:ea typeface="Arial" pitchFamily="34" charset="-122"/>
                 <a:cs typeface="Arial" pitchFamily="34" charset="-120"/>
               </a:rPr>
-              <a:t>Reflect with context-aware guidance while keeping AI boundaries clear.</a:t>
+              <a:t>Use guided conversation without pretending to be a clinician.</a:t>
             </a:r>
             <a:endParaRPr lang="en-US" sz="1300" dirty="0"/>
           </a:p>
@@ -4123,7 +4096,7 @@
                 <a:ea typeface="Arial" pitchFamily="34" charset="-122"/>
                 <a:cs typeface="Arial" pitchFamily="34" charset="-120"/>
               </a:rPr>
-              <a:t>Talk it through safely.</a:t>
+              <a:t>Talk it through safely</a:t>
             </a:r>
             <a:endParaRPr lang="en-US" sz="1050" dirty="0"/>
           </a:p>
@@ -4234,7 +4207,7 @@
                 <a:ea typeface="Arial" pitchFamily="34" charset="-122"/>
                 <a:cs typeface="Arial" pitchFamily="34" charset="-120"/>
               </a:rPr>
-              <a:t>Move toward trusted, professional, and emergency support when needed.</a:t>
+              <a:t>Move to trusted, professional, or emergency help when needed.</a:t>
             </a:r>
             <a:endParaRPr lang="en-US" sz="1300" dirty="0"/>
           </a:p>
@@ -4275,7 +4248,7 @@
                 <a:ea typeface="Arial" pitchFamily="34" charset="-122"/>
                 <a:cs typeface="Arial" pitchFamily="34" charset="-120"/>
               </a:rPr>
-              <a:t>Human support stays within reach.</a:t>
+              <a:t>Know where to go next</a:t>
             </a:r>
             <a:endParaRPr lang="en-US" sz="1050" dirty="0"/>
           </a:p>
@@ -4471,7 +4444,7 @@
                 <a:ea typeface="Arial" pitchFamily="34" charset="-122"/>
                 <a:cs typeface="Arial" pitchFamily="34" charset="-120"/>
               </a:rPr>
-              <a:t>Safe support, with clear boundaries</a:t>
+              <a:t>Helpful support, with clear boundaries</a:t>
             </a:r>
             <a:endParaRPr lang="en-US" sz="2800" dirty="0"/>
           </a:p>
@@ -4512,7 +4485,7 @@
                 <a:ea typeface="Arial" pitchFamily="34" charset="-122"/>
                 <a:cs typeface="Arial" pitchFamily="34" charset="-120"/>
               </a:rPr>
-              <a:t>MindMate is helpful inside clear boundaries.</a:t>
+              <a:t>MindMate supports the user without pretending to replace human care.</a:t>
             </a:r>
             <a:endParaRPr lang="en-US" sz="1300" dirty="0"/>
           </a:p>
@@ -4582,7 +4555,7 @@
                 <a:ea typeface="Arial" pitchFamily="34" charset="-122"/>
                 <a:cs typeface="Arial" pitchFamily="34" charset="-120"/>
               </a:rPr>
-              <a:t>01 / WHAT MINDMATE DOES</a:t>
+              <a:t>01 / SUPPORT</a:t>
             </a:r>
             <a:endParaRPr lang="en-US" sz="1350" dirty="0"/>
           </a:p>
@@ -4623,7 +4596,7 @@
                 <a:ea typeface="Arial" pitchFamily="34" charset="-122"/>
                 <a:cs typeface="Arial" pitchFamily="34" charset="-120"/>
               </a:rPr>
-              <a:t>MindMate acknowledges what the user is experiencing, offers one practical next step, and keeps human support visible.</a:t>
+              <a:t>MindMate listens, reflects what the user shares, and offers one practical next step.</a:t>
             </a:r>
             <a:endParaRPr lang="en-US" sz="1300" dirty="0"/>
           </a:p>
@@ -4734,7 +4707,7 @@
                 <a:ea typeface="Arial" pitchFamily="34" charset="-122"/>
                 <a:cs typeface="Arial" pitchFamily="34" charset="-120"/>
               </a:rPr>
-              <a:t>02 / WHEN RISK APPEARS</a:t>
+              <a:t>02 / RISK</a:t>
             </a:r>
             <a:endParaRPr lang="en-US" sz="1350" dirty="0"/>
           </a:p>
@@ -4775,7 +4748,7 @@
                 <a:ea typeface="Arial" pitchFamily="34" charset="-122"/>
                 <a:cs typeface="Arial" pitchFamily="34" charset="-120"/>
               </a:rPr>
-              <a:t>When more immediate support may be needed, MindMate moves the user toward a clear Emergency Support option rather than handling the situation alone.</a:t>
+              <a:t>When urgent help may be needed, MindMate points the user toward Emergency Support.</a:t>
             </a:r>
             <a:endParaRPr lang="en-US" sz="1300" dirty="0"/>
           </a:p>
@@ -4816,7 +4789,7 @@
                 <a:ea typeface="Arial" pitchFamily="34" charset="-122"/>
                 <a:cs typeface="Arial" pitchFamily="34" charset="-120"/>
               </a:rPr>
-              <a:t>A clear route to immediate support</a:t>
+              <a:t>A clear route to help</a:t>
             </a:r>
             <a:endParaRPr lang="en-US" sz="1050" dirty="0"/>
           </a:p>
@@ -4886,7 +4859,7 @@
                 <a:ea typeface="Arial" pitchFamily="34" charset="-122"/>
                 <a:cs typeface="Arial" pitchFamily="34" charset="-120"/>
               </a:rPr>
-              <a:t>03 / WHAT IT WILL NOT DO</a:t>
+              <a:t>03 / LIMITS</a:t>
             </a:r>
             <a:endParaRPr lang="en-US" sz="1350" dirty="0"/>
           </a:p>
@@ -4927,7 +4900,7 @@
                 <a:ea typeface="Arial" pitchFamily="34" charset="-122"/>
                 <a:cs typeface="Arial" pitchFamily="34" charset="-120"/>
               </a:rPr>
-              <a:t>MindMate does not replace professional care, make clinical decisions, or take action outside the user’s control.</a:t>
+              <a:t>MindMate does not diagnose, replace professional care, or act outside the user’s control.</a:t>
             </a:r>
             <a:endParaRPr lang="en-US" sz="1300" dirty="0"/>
           </a:p>
@@ -4968,7 +4941,7 @@
                 <a:ea typeface="Arial" pitchFamily="34" charset="-122"/>
                 <a:cs typeface="Arial" pitchFamily="34" charset="-120"/>
               </a:rPr>
-              <a:t>Clear boundaries. User control.</a:t>
+              <a:t>Clear limits. User control.</a:t>
             </a:r>
             <a:endParaRPr lang="en-US" sz="1050" dirty="0"/>
           </a:p>
@@ -5234,7 +5207,7 @@
                 <a:ea typeface="Arial" pitchFamily="34" charset="-122"/>
                 <a:cs typeface="Arial" pitchFamily="34" charset="-120"/>
               </a:rPr>
-              <a:t>MindMate brings the whole support journey together</a:t>
+              <a:t>MindMate brings the support journey together</a:t>
             </a:r>
             <a:endParaRPr lang="en-US" sz="2800" dirty="0"/>
           </a:p>
@@ -5275,7 +5248,7 @@
                 <a:ea typeface="Arial" pitchFamily="34" charset="-122"/>
                 <a:cs typeface="Arial" pitchFamily="34" charset="-120"/>
               </a:rPr>
-              <a:t>Many wellbeing tools focus on one part of the experience. MindMate connects awareness, action, conversation, and human support.</a:t>
+              <a:t>It connects the check-in, the next step, the conversation, and the route to human help.</a:t>
             </a:r>
             <a:endParaRPr lang="en-US" sz="1300" dirty="0"/>
           </a:p>
@@ -5456,7 +5429,7 @@
                 <a:ea typeface="Arial" pitchFamily="34" charset="-122"/>
                 <a:cs typeface="Arial" pitchFamily="34" charset="-120"/>
               </a:rPr>
-              <a:t>A mood score or reflection space may not explain what to do next.</a:t>
+              <a:t>A mood score may not explain what to do next.</a:t>
             </a:r>
             <a:endParaRPr lang="en-US" sz="1150" dirty="0"/>
           </a:p>
@@ -5567,7 +5540,7 @@
                 <a:ea typeface="Arial" pitchFamily="34" charset="-122"/>
                 <a:cs typeface="Arial" pitchFamily="34" charset="-120"/>
               </a:rPr>
-              <a:t>Turns the check-in into a starting point for a personalised next step.</a:t>
+              <a:t>Turns the check-in into a useful starting point.</a:t>
             </a:r>
             <a:endParaRPr lang="en-US" sz="1150" dirty="0"/>
           </a:p>
@@ -5707,7 +5680,7 @@
                 <a:ea typeface="Arial" pitchFamily="34" charset="-122"/>
                 <a:cs typeface="Arial" pitchFamily="34" charset="-120"/>
               </a:rPr>
-              <a:t>WELLBEING TOOLS</a:t>
+              <a:t>TOOLS</a:t>
             </a:r>
             <a:endParaRPr lang="en-US" sz="1100" dirty="0"/>
           </a:p>
@@ -5818,7 +5791,7 @@
                 <a:ea typeface="Arial" pitchFamily="34" charset="-122"/>
                 <a:cs typeface="Arial" pitchFamily="34" charset="-120"/>
               </a:rPr>
-              <a:t>Multiple exercises or articles can make it hard to know which one fits the moment.</a:t>
+              <a:t>A long list of exercises can create more choice, not more clarity.</a:t>
             </a:r>
             <a:endParaRPr lang="en-US" sz="1150" dirty="0"/>
           </a:p>
@@ -5929,7 +5902,7 @@
                 <a:ea typeface="Arial" pitchFamily="34" charset="-122"/>
                 <a:cs typeface="Arial" pitchFamily="34" charset="-120"/>
               </a:rPr>
-              <a:t>Guides the user toward one manageable action, with alternatives when needed.</a:t>
+              <a:t>Offers one manageable action at a time.</a:t>
             </a:r>
             <a:endParaRPr lang="en-US" sz="1150" dirty="0"/>
           </a:p>
@@ -5999,7 +5972,7 @@
                 <a:ea typeface="Arial" pitchFamily="34" charset="-122"/>
                 <a:cs typeface="Arial" pitchFamily="34" charset="-120"/>
               </a:rPr>
-              <a:t>Less overwhelm → clearer action</a:t>
+              <a:t>Less choice → clearer action</a:t>
             </a:r>
             <a:endParaRPr lang="en-US" sz="1200" dirty="0"/>
           </a:p>
@@ -6180,7 +6153,7 @@
                 <a:ea typeface="Arial" pitchFamily="34" charset="-122"/>
                 <a:cs typeface="Arial" pitchFamily="34" charset="-120"/>
               </a:rPr>
-              <a:t>Self-guided tools may focus mainly on what happens inside the app.</a:t>
+              <a:t>Self-guided tools can leave the user alone when more help is needed.</a:t>
             </a:r>
             <a:endParaRPr lang="en-US" sz="1150" dirty="0"/>
           </a:p>
@@ -6291,7 +6264,7 @@
                 <a:ea typeface="Arial" pitchFamily="34" charset="-122"/>
                 <a:cs typeface="Arial" pitchFamily="34" charset="-120"/>
               </a:rPr>
-              <a:t>Keeps trusted human and emergency support visible when more help is needed.</a:t>
+              <a:t>Keeps trusted and emergency support visible.</a:t>
             </a:r>
             <a:endParaRPr lang="en-US" sz="1150" dirty="0"/>
           </a:p>
@@ -6431,7 +6404,7 @@
                 <a:ea typeface="Arial" pitchFamily="34" charset="-122"/>
                 <a:cs typeface="Arial" pitchFamily="34" charset="-120"/>
               </a:rPr>
-              <a:t>MindMate is designed around the journey, not just the individual feature.</a:t>
+              <a:t>MindMate is built around the journey, not just one feature.</a:t>
             </a:r>
             <a:endParaRPr lang="en-US" sz="1200" dirty="0"/>
           </a:p>
@@ -6627,7 +6600,7 @@
                 <a:ea typeface="Arial" pitchFamily="34" charset="-122"/>
                 <a:cs typeface="Arial" pitchFamily="34" charset="-120"/>
               </a:rPr>
-              <a:t>Built, tested, and ready for a real user journey</a:t>
+              <a:t>Built, tested, and ready to show</a:t>
             </a:r>
             <a:endParaRPr lang="en-US" sz="2800" dirty="0"/>
           </a:p>
@@ -6668,7 +6641,7 @@
                 <a:ea typeface="Arial" pitchFamily="34" charset="-122"/>
                 <a:cs typeface="Arial" pitchFamily="34" charset="-120"/>
               </a:rPr>
-              <a:t>MindMate is already running across Android and Web, with its core experience tested from check-in through support.</a:t>
+              <a:t>MindMate is running on Android and Web, with the main user journeys checked from check-in through support.</a:t>
             </a:r>
             <a:endParaRPr lang="en-US" sz="1300" dirty="0"/>
           </a:p>
@@ -6738,7 +6711,7 @@
                 <a:ea typeface="Arial" pitchFamily="34" charset="-122"/>
                 <a:cs typeface="Arial" pitchFamily="34" charset="-120"/>
               </a:rPr>
-              <a:t>READY ON ANDROID</a:t>
+              <a:t>ANDROID RELEASE</a:t>
             </a:r>
             <a:endParaRPr lang="en-US" sz="1350" dirty="0"/>
           </a:p>
@@ -6779,7 +6752,7 @@
                 <a:ea typeface="Arial" pitchFamily="34" charset="-122"/>
                 <a:cs typeface="Arial" pitchFamily="34" charset="-120"/>
               </a:rPr>
-              <a:t>MindMate has a signed Android release that can be installed and used as a complete product experience.</a:t>
+              <a:t>An installable Android build is ready for demonstration and use.</a:t>
             </a:r>
             <a:endParaRPr lang="en-US" sz="1300" dirty="0"/>
           </a:p>
@@ -6820,7 +6793,7 @@
                 <a:ea typeface="Arial" pitchFamily="34" charset="-122"/>
                 <a:cs typeface="Arial" pitchFamily="34" charset="-120"/>
               </a:rPr>
-              <a:t>Built for real use</a:t>
+              <a:t>Ready to install</a:t>
             </a:r>
             <a:endParaRPr lang="en-US" sz="1050" dirty="0"/>
           </a:p>
@@ -6890,7 +6863,7 @@
                 <a:ea typeface="Arial" pitchFamily="34" charset="-122"/>
                 <a:cs typeface="Arial" pitchFamily="34" charset="-120"/>
               </a:rPr>
-              <a:t>LIVE ON THE WEB</a:t>
+              <a:t>WEB RELEASE</a:t>
             </a:r>
             <a:endParaRPr lang="en-US" sz="1350" dirty="0"/>
           </a:p>
@@ -6931,7 +6904,7 @@
                 <a:ea typeface="Arial" pitchFamily="34" charset="-122"/>
                 <a:cs typeface="Arial" pitchFamily="34" charset="-120"/>
               </a:rPr>
-              <a:t>MindMate is hosted as a live Web release, making the product easier to access, share, and demonstrate across devices.</a:t>
+              <a:t>A live Web version makes MindMate easy to access and share.</a:t>
             </a:r>
             <a:endParaRPr lang="en-US" sz="1300" dirty="0"/>
           </a:p>
@@ -6972,7 +6945,7 @@
                 <a:ea typeface="Arial" pitchFamily="34" charset="-122"/>
                 <a:cs typeface="Arial" pitchFamily="34" charset="-120"/>
               </a:rPr>
-              <a:t>Easy to access + share</a:t>
+              <a:t>Easy to try and share</a:t>
             </a:r>
             <a:endParaRPr lang="en-US" sz="1050" dirty="0"/>
           </a:p>
@@ -7042,7 +7015,7 @@
                 <a:ea typeface="Arial" pitchFamily="34" charset="-122"/>
                 <a:cs typeface="Arial" pitchFamily="34" charset="-120"/>
               </a:rPr>
-              <a:t>CORE JOURNEYS VERIFIED</a:t>
+              <a:t>MAIN JOURNEYS CHECKED</a:t>
             </a:r>
             <a:endParaRPr lang="en-US" sz="1350" dirty="0"/>
           </a:p>
@@ -7083,7 +7056,7 @@
                 <a:ea typeface="Arial" pitchFamily="34" charset="-122"/>
                 <a:cs typeface="Arial" pitchFamily="34" charset="-120"/>
               </a:rPr>
-              <a:t>The journeys that matter most have been tested, including core features, safety behaviour, and different layouts.</a:t>
+              <a:t>The core features, safety behaviour, and layouts have been tested.</a:t>
             </a:r>
             <a:endParaRPr lang="en-US" sz="1300" dirty="0"/>
           </a:p>
@@ -7124,7 +7097,7 @@
                 <a:ea typeface="Arial" pitchFamily="34" charset="-122"/>
                 <a:cs typeface="Arial" pitchFamily="34" charset="-120"/>
               </a:rPr>
-              <a:t>The experience was tested, not just built</a:t>
+              <a:t>Built and tested</a:t>
             </a:r>
             <a:endParaRPr lang="en-US" sz="1050" dirty="0"/>
           </a:p>
@@ -7194,7 +7167,7 @@
                 <a:ea typeface="Arial" pitchFamily="34" charset="-122"/>
                 <a:cs typeface="Arial" pitchFamily="34" charset="-120"/>
               </a:rPr>
-              <a:t>The point: we tested the experience, not just the idea.</a:t>
+              <a:t>The point: MindMate is more than an idea — it is ready to demonstrate.</a:t>
             </a:r>
             <a:endParaRPr lang="en-US" sz="1400" dirty="0"/>
           </a:p>
@@ -7390,7 +7363,7 @@
                 <a:ea typeface="Arial" pitchFamily="34" charset="-122"/>
                 <a:cs typeface="Arial" pitchFamily="34" charset="-120"/>
               </a:rPr>
-              <a:t>Keep access free for young people while building a sustainable revenue path</a:t>
+              <a:t>A free core, with paid features later</a:t>
             </a:r>
             <a:endParaRPr lang="en-US" sz="2800" dirty="0"/>
           </a:p>
@@ -7431,7 +7404,7 @@
                 <a:ea typeface="Arial" pitchFamily="34" charset="-122"/>
                 <a:cs typeface="Arial" pitchFamily="34" charset="-120"/>
               </a:rPr>
-              <a:t>Young people get the essential journey; future funding and paid extensions can support sustainability.</a:t>
+              <a:t>MindMate can stay accessible while a premium plan supports future sustainability.</a:t>
             </a:r>
             <a:endParaRPr lang="en-US" sz="1300" dirty="0"/>
           </a:p>
@@ -7445,12 +7418,12 @@
         </p:nvSpPr>
         <p:spPr>
           <a:xfrm>
-            <a:off x="658368" y="2148840"/>
-            <a:ext cx="3401568" cy="3319272"/>
+            <a:off x="658368" y="2029968"/>
+            <a:ext cx="3401568" cy="3584448"/>
           </a:xfrm>
           <a:prstGeom prst="roundRect">
             <a:avLst>
-              <a:gd name="adj" fmla="val 2204"/>
+              <a:gd name="adj" fmla="val 2151"/>
             </a:avLst>
           </a:prstGeom>
           <a:solidFill>
@@ -7474,8 +7447,8 @@
         </p:nvSpPr>
         <p:spPr>
           <a:xfrm>
-            <a:off x="914400" y="2468880"/>
-            <a:ext cx="2743200" cy="201168"/>
+            <a:off x="914400" y="2331720"/>
+            <a:ext cx="2852928" cy="201168"/>
           </a:xfrm>
           <a:prstGeom prst="rect">
             <a:avLst/>
@@ -7501,7 +7474,7 @@
                 <a:ea typeface="Arial" pitchFamily="34" charset="-122"/>
                 <a:cs typeface="Arial" pitchFamily="34" charset="-120"/>
               </a:rPr>
-              <a:t>FREE USER</a:t>
+              <a:t>FREE ACCESS</a:t>
             </a:r>
             <a:endParaRPr lang="en-US" sz="1000" dirty="0"/>
           </a:p>
@@ -7515,26 +7488,26 @@
         </p:nvSpPr>
         <p:spPr>
           <a:xfrm>
-            <a:off x="914400" y="2852928"/>
-            <a:ext cx="2743200" cy="329184"/>
-          </a:xfrm>
-          <a:prstGeom prst="rect">
-            <a:avLst/>
-          </a:prstGeom>
-          <a:noFill/>
-          <a:ln/>
-        </p:spPr>
-        <p:txBody>
-          <a:bodyPr wrap="square" lIns="0" tIns="0" rIns="0" bIns="0" rtlCol="0" anchor="ctr">
-            <a:normAutofit/>
-          </a:bodyPr>
-          <a:lstStyle/>
-          <a:p>
-            <a:pPr algn="l" indent="0" marL="0">
-              <a:buNone/>
-            </a:pPr>
-            <a:r>
-              <a:rPr lang="en-US" sz="2000" b="1" dirty="0">
+            <a:off x="914400" y="2688336"/>
+            <a:ext cx="2852928" cy="329184"/>
+          </a:xfrm>
+          <a:prstGeom prst="rect">
+            <a:avLst/>
+          </a:prstGeom>
+          <a:noFill/>
+          <a:ln/>
+        </p:spPr>
+        <p:txBody>
+          <a:bodyPr wrap="square" lIns="0" tIns="0" rIns="0" bIns="0" rtlCol="0" anchor="ctr">
+            <a:normAutofit/>
+          </a:bodyPr>
+          <a:lstStyle/>
+          <a:p>
+            <a:pPr algn="l" indent="0" marL="0">
+              <a:buNone/>
+            </a:pPr>
+            <a:r>
+              <a:rPr lang="en-US" sz="1900" b="1" dirty="0">
                 <a:solidFill>
                   <a:srgbClr val="12232B"/>
                 </a:solidFill>
@@ -7542,9 +7515,9 @@
                 <a:ea typeface="Arial" pitchFamily="34" charset="-122"/>
                 <a:cs typeface="Arial" pitchFamily="34" charset="-120"/>
               </a:rPr>
-              <a:t>YOUNG PERSON</a:t>
-            </a:r>
-            <a:endParaRPr lang="en-US" sz="2000" dirty="0"/>
+              <a:t>BASIC MINDMATE</a:t>
+            </a:r>
+            <a:endParaRPr lang="en-US" sz="1900" dirty="0"/>
           </a:p>
         </p:txBody>
       </p:sp>
@@ -7556,8 +7529,8 @@
         </p:nvSpPr>
         <p:spPr>
           <a:xfrm>
-            <a:off x="914400" y="3456432"/>
-            <a:ext cx="2798064" cy="1463040"/>
+            <a:off x="914400" y="3364992"/>
+            <a:ext cx="2816352" cy="1645920"/>
           </a:xfrm>
           <a:prstGeom prst="rect">
             <a:avLst/>
@@ -7583,7 +7556,7 @@
                 <a:ea typeface="Arial" pitchFamily="34" charset="-122"/>
                 <a:cs typeface="Arial" pitchFamily="34" charset="-120"/>
               </a:rPr>
-              <a:t>Essential MindMate journey:</a:t>
+              <a:t>• Check-ins + reflection</a:t>
             </a:r>
             <a:endParaRPr lang="en-US" sz="1230" dirty="0"/>
           </a:p>
@@ -7600,7 +7573,7 @@
                 <a:ea typeface="Arial" pitchFamily="34" charset="-122"/>
                 <a:cs typeface="Arial" pitchFamily="34" charset="-120"/>
               </a:rPr>
-              <a:t>• Check-ins + next steps</a:t>
+              <a:t>• Basic next-step guidance</a:t>
             </a:r>
             <a:endParaRPr lang="en-US" sz="1230" dirty="0"/>
           </a:p>
@@ -7617,7 +7590,7 @@
                 <a:ea typeface="Arial" pitchFamily="34" charset="-122"/>
                 <a:cs typeface="Arial" pitchFamily="34" charset="-120"/>
               </a:rPr>
-              <a:t>• Chat + journaling</a:t>
+              <a:t>• Journaling + wellbeing tools</a:t>
             </a:r>
             <a:endParaRPr lang="en-US" sz="1230" dirty="0"/>
           </a:p>
@@ -7634,27 +7607,10 @@
                 <a:ea typeface="Arial" pitchFamily="34" charset="-122"/>
                 <a:cs typeface="Arial" pitchFamily="34" charset="-120"/>
               </a:rPr>
-              <a:t>• Breathing / meditation</a:t>
+              <a:t>• Support routes</a:t>
             </a:r>
             <a:endParaRPr lang="en-US" sz="1230" dirty="0"/>
           </a:p>
-          <a:p>
-            <a:pPr algn="l" indent="0" marL="0">
-              <a:buNone/>
-            </a:pPr>
-            <a:r>
-              <a:rPr lang="en-US" sz="1230" dirty="0">
-                <a:solidFill>
-                  <a:srgbClr val="182A35"/>
-                </a:solidFill>
-                <a:latin typeface="Arial" pitchFamily="34" charset="0"/>
-                <a:ea typeface="Arial" pitchFamily="34" charset="-122"/>
-                <a:cs typeface="Arial" pitchFamily="34" charset="-120"/>
-              </a:rPr>
-              <a:t>• Learn + support routes</a:t>
-            </a:r>
-            <a:endParaRPr lang="en-US" sz="1230" dirty="0"/>
-          </a:p>
         </p:txBody>
       </p:sp>
       <p:sp>
@@ -7665,7 +7621,7 @@
         </p:nvSpPr>
         <p:spPr>
           <a:xfrm>
-            <a:off x="4114800" y="3493008"/>
+            <a:off x="4114800" y="3529584"/>
             <a:ext cx="274320" cy="320040"/>
           </a:xfrm>
           <a:prstGeom prst="rect">
@@ -7706,12 +7662,12 @@
         </p:nvSpPr>
         <p:spPr>
           <a:xfrm>
-            <a:off x="4425696" y="2148840"/>
-            <a:ext cx="3401568" cy="3319272"/>
+            <a:off x="4425696" y="2029968"/>
+            <a:ext cx="3401568" cy="3584448"/>
           </a:xfrm>
           <a:prstGeom prst="roundRect">
             <a:avLst>
-              <a:gd name="adj" fmla="val 2204"/>
+              <a:gd name="adj" fmla="val 2151"/>
             </a:avLst>
           </a:prstGeom>
           <a:solidFill>
@@ -7735,8 +7691,8 @@
         </p:nvSpPr>
         <p:spPr>
           <a:xfrm>
-            <a:off x="4681728" y="2468880"/>
-            <a:ext cx="2743200" cy="201168"/>
+            <a:off x="4681728" y="2331720"/>
+            <a:ext cx="2852928" cy="201168"/>
           </a:xfrm>
           <a:prstGeom prst="rect">
             <a:avLst/>
@@ -7762,7 +7718,7 @@
                 <a:ea typeface="Arial" pitchFamily="34" charset="-122"/>
                 <a:cs typeface="Arial" pitchFamily="34" charset="-120"/>
               </a:rPr>
-              <a:t>WHO PAYS</a:t>
+              <a:t>MINDMATE PLUS</a:t>
             </a:r>
             <a:endParaRPr lang="en-US" sz="1000" dirty="0"/>
           </a:p>
@@ -7776,26 +7732,26 @@
         </p:nvSpPr>
         <p:spPr>
           <a:xfrm>
-            <a:off x="4681728" y="2852928"/>
-            <a:ext cx="2743200" cy="329184"/>
-          </a:xfrm>
-          <a:prstGeom prst="rect">
-            <a:avLst/>
-          </a:prstGeom>
-          <a:noFill/>
-          <a:ln/>
-        </p:spPr>
-        <p:txBody>
-          <a:bodyPr wrap="square" lIns="0" tIns="0" rIns="0" bIns="0" rtlCol="0" anchor="ctr">
-            <a:normAutofit/>
-          </a:bodyPr>
-          <a:lstStyle/>
-          <a:p>
-            <a:pPr algn="l" indent="0" marL="0">
-              <a:buNone/>
-            </a:pPr>
-            <a:r>
-              <a:rPr lang="en-US" sz="2000" b="1" dirty="0">
+            <a:off x="4681728" y="2688336"/>
+            <a:ext cx="2852928" cy="329184"/>
+          </a:xfrm>
+          <a:prstGeom prst="rect">
+            <a:avLst/>
+          </a:prstGeom>
+          <a:noFill/>
+          <a:ln/>
+        </p:spPr>
+        <p:txBody>
+          <a:bodyPr wrap="square" lIns="0" tIns="0" rIns="0" bIns="0" rtlCol="0" anchor="ctr">
+            <a:normAutofit/>
+          </a:bodyPr>
+          <a:lstStyle/>
+          <a:p>
+            <a:pPr algn="l" indent="0" marL="0">
+              <a:buNone/>
+            </a:pPr>
+            <a:r>
+              <a:rPr lang="en-US" sz="1900" b="1" dirty="0">
                 <a:solidFill>
                   <a:srgbClr val="12232B"/>
                 </a:solidFill>
@@ -7803,9 +7759,9 @@
                 <a:ea typeface="Arial" pitchFamily="34" charset="-122"/>
                 <a:cs typeface="Arial" pitchFamily="34" charset="-120"/>
               </a:rPr>
-              <a:t>ORGANISATIONS</a:t>
-            </a:r>
-            <a:endParaRPr lang="en-US" sz="2000" dirty="0"/>
+              <a:t>PLANNED FEATURES</a:t>
+            </a:r>
+            <a:endParaRPr lang="en-US" sz="1900" dirty="0"/>
           </a:p>
         </p:txBody>
       </p:sp>
@@ -7817,8 +7773,8 @@
         </p:nvSpPr>
         <p:spPr>
           <a:xfrm>
-            <a:off x="4681728" y="3456432"/>
-            <a:ext cx="2798064" cy="1463040"/>
+            <a:off x="4681728" y="3364992"/>
+            <a:ext cx="2816352" cy="1645920"/>
           </a:xfrm>
           <a:prstGeom prst="rect">
             <a:avLst/>
@@ -7844,7 +7800,7 @@
                 <a:ea typeface="Arial" pitchFamily="34" charset="-122"/>
                 <a:cs typeface="Arial" pitchFamily="34" charset="-120"/>
               </a:rPr>
-              <a:t>Potential customers or funders to validate:</a:t>
+              <a:t>• Guided routines</a:t>
             </a:r>
             <a:endParaRPr lang="en-US" sz="1230" dirty="0"/>
           </a:p>
@@ -7861,7 +7817,7 @@
                 <a:ea typeface="Arial" pitchFamily="34" charset="-122"/>
                 <a:cs typeface="Arial" pitchFamily="34" charset="-120"/>
               </a:rPr>
-              <a:t>• Youth organisations / NGOs</a:t>
+              <a:t>• Progress tools</a:t>
             </a:r>
             <a:endParaRPr lang="en-US" sz="1230" dirty="0"/>
           </a:p>
@@ -7878,7 +7834,7 @@
                 <a:ea typeface="Arial" pitchFamily="34" charset="-122"/>
                 <a:cs typeface="Arial" pitchFamily="34" charset="-120"/>
               </a:rPr>
-              <a:t>• Foundations + CSR programmes</a:t>
+              <a:t>• Additional wellbeing content</a:t>
             </a:r>
             <a:endParaRPr lang="en-US" sz="1230" dirty="0"/>
           </a:p>
@@ -7895,27 +7851,10 @@
                 <a:ea typeface="Arial" pitchFamily="34" charset="-122"/>
                 <a:cs typeface="Arial" pitchFamily="34" charset="-120"/>
               </a:rPr>
-              <a:t>• Sponsored access</a:t>
+              <a:t>• Future features to validate</a:t>
             </a:r>
             <a:endParaRPr lang="en-US" sz="1230" dirty="0"/>
           </a:p>
-          <a:p>
-            <a:pPr algn="l" indent="0" marL="0">
-              <a:buNone/>
-            </a:pPr>
-            <a:r>
-              <a:rPr lang="en-US" sz="1230" dirty="0">
-                <a:solidFill>
-                  <a:srgbClr val="182A35"/>
-                </a:solidFill>
-                <a:latin typeface="Arial" pitchFamily="34" charset="0"/>
-                <a:ea typeface="Arial" pitchFamily="34" charset="-122"/>
-                <a:cs typeface="Arial" pitchFamily="34" charset="-120"/>
-              </a:rPr>
-              <a:t>• Workshops + implementation</a:t>
-            </a:r>
-            <a:endParaRPr lang="en-US" sz="1230" dirty="0"/>
-          </a:p>
         </p:txBody>
       </p:sp>
       <p:sp>
@@ -7926,7 +7865,7 @@
         </p:nvSpPr>
         <p:spPr>
           <a:xfrm>
-            <a:off x="7882128" y="3493008"/>
+            <a:off x="7882128" y="3529584"/>
             <a:ext cx="274320" cy="320040"/>
           </a:xfrm>
           <a:prstGeom prst="rect">
@@ -7967,12 +7906,12 @@
         </p:nvSpPr>
         <p:spPr>
           <a:xfrm>
-            <a:off x="8193024" y="2148840"/>
-            <a:ext cx="3401568" cy="3319272"/>
+            <a:off x="8193024" y="2029968"/>
+            <a:ext cx="3401568" cy="3584448"/>
           </a:xfrm>
           <a:prstGeom prst="roundRect">
             <a:avLst>
-              <a:gd name="adj" fmla="val 2204"/>
+              <a:gd name="adj" fmla="val 2151"/>
             </a:avLst>
           </a:prstGeom>
           <a:solidFill>
@@ -7996,8 +7935,8 @@
         </p:nvSpPr>
         <p:spPr>
           <a:xfrm>
-            <a:off x="8449056" y="2468880"/>
-            <a:ext cx="2743200" cy="201168"/>
+            <a:off x="8449056" y="2331720"/>
+            <a:ext cx="2852928" cy="201168"/>
           </a:xfrm>
           <a:prstGeom prst="rect">
             <a:avLst/>
@@ -8023,7 +7962,7 @@
                 <a:ea typeface="Arial" pitchFamily="34" charset="-122"/>
                 <a:cs typeface="Arial" pitchFamily="34" charset="-120"/>
               </a:rPr>
-              <a:t>FUTURE REVENUE</a:t>
+              <a:t>EXAMPLE SCENARIO</a:t>
             </a:r>
             <a:endParaRPr lang="en-US" sz="1000" dirty="0"/>
           </a:p>
@@ -8037,26 +7976,26 @@
         </p:nvSpPr>
         <p:spPr>
           <a:xfrm>
-            <a:off x="8449056" y="2852928"/>
-            <a:ext cx="2743200" cy="329184"/>
-          </a:xfrm>
-          <a:prstGeom prst="rect">
-            <a:avLst/>
-          </a:prstGeom>
-          <a:noFill/>
-          <a:ln/>
-        </p:spPr>
-        <p:txBody>
-          <a:bodyPr wrap="square" lIns="0" tIns="0" rIns="0" bIns="0" rtlCol="0" anchor="ctr">
-            <a:normAutofit/>
-          </a:bodyPr>
-          <a:lstStyle/>
-          <a:p>
-            <a:pPr algn="l" indent="0" marL="0">
-              <a:buNone/>
-            </a:pPr>
-            <a:r>
-              <a:rPr lang="en-US" sz="2000" b="1" dirty="0">
+            <a:off x="8449056" y="2688336"/>
+            <a:ext cx="2852928" cy="329184"/>
+          </a:xfrm>
+          <a:prstGeom prst="rect">
+            <a:avLst/>
+          </a:prstGeom>
+          <a:noFill/>
+          <a:ln/>
+        </p:spPr>
+        <p:txBody>
+          <a:bodyPr wrap="square" lIns="0" tIns="0" rIns="0" bIns="0" rtlCol="0" anchor="ctr">
+            <a:normAutofit/>
+          </a:bodyPr>
+          <a:lstStyle/>
+          <a:p>
+            <a:pPr algn="l" indent="0" marL="0">
+              <a:buNone/>
+            </a:pPr>
+            <a:r>
+              <a:rPr lang="en-US" sz="1900" b="1" dirty="0">
                 <a:solidFill>
                   <a:srgbClr val="FFFFFF"/>
                 </a:solidFill>
@@ -8064,9 +8003,9 @@
                 <a:ea typeface="Arial" pitchFamily="34" charset="-122"/>
                 <a:cs typeface="Arial" pitchFamily="34" charset="-120"/>
               </a:rPr>
-              <a:t>OPTIONAL PAID</a:t>
-            </a:r>
-            <a:endParaRPr lang="en-US" sz="2000" dirty="0"/>
+              <a:t>FUTURE INCOME</a:t>
+            </a:r>
+            <a:endParaRPr lang="en-US" sz="1900" dirty="0"/>
           </a:p>
         </p:txBody>
       </p:sp>
@@ -8078,8 +8017,8 @@
         </p:nvSpPr>
         <p:spPr>
           <a:xfrm>
-            <a:off x="8449056" y="3456432"/>
-            <a:ext cx="2798064" cy="1463040"/>
+            <a:off x="8449056" y="3364992"/>
+            <a:ext cx="2816352" cy="1645920"/>
           </a:xfrm>
           <a:prstGeom prst="rect">
             <a:avLst/>
@@ -8105,7 +8044,7 @@
                 <a:ea typeface="Arial" pitchFamily="34" charset="-122"/>
                 <a:cs typeface="Arial" pitchFamily="34" charset="-120"/>
               </a:rPr>
-              <a:t>Only after validating what users value:</a:t>
+              <a:t>₦10,000 per year × 500 paid users</a:t>
             </a:r>
             <a:endParaRPr lang="en-US" sz="1230" dirty="0"/>
           </a:p>
@@ -8113,6 +8052,12 @@
             <a:pPr algn="l" indent="0" marL="0">
               <a:buNone/>
             </a:pPr>
+            <a:endParaRPr lang="en-US" sz="1230" dirty="0"/>
+          </a:p>
+          <a:p>
+            <a:pPr algn="l" indent="0" marL="0">
+              <a:buNone/>
+            </a:pPr>
             <a:r>
               <a:rPr lang="en-US" sz="1230" dirty="0">
                 <a:solidFill>
@@ -8122,44 +8067,10 @@
                 <a:ea typeface="Arial" pitchFamily="34" charset="-122"/>
                 <a:cs typeface="Arial" pitchFamily="34" charset="-120"/>
               </a:rPr>
-              <a:t>• Wellbeing programmes</a:t>
+              <a:t>= ₦5,000,000 projected annual income</a:t>
             </a:r>
             <a:endParaRPr lang="en-US" sz="1230" dirty="0"/>
           </a:p>
-          <a:p>
-            <a:pPr algn="l" indent="0" marL="0">
-              <a:buNone/>
-            </a:pPr>
-            <a:r>
-              <a:rPr lang="en-US" sz="1230" dirty="0">
-                <a:solidFill>
-                  <a:srgbClr val="D2E2DE"/>
-                </a:solidFill>
-                <a:latin typeface="Arial" pitchFamily="34" charset="0"/>
-                <a:ea typeface="Arial" pitchFamily="34" charset="-122"/>
-                <a:cs typeface="Arial" pitchFamily="34" charset="-120"/>
-              </a:rPr>
-              <a:t>• Additional guided content</a:t>
-            </a:r>
-            <a:endParaRPr lang="en-US" sz="1230" dirty="0"/>
-          </a:p>
-          <a:p>
-            <a:pPr algn="l" indent="0" marL="0">
-              <a:buNone/>
-            </a:pPr>
-            <a:r>
-              <a:rPr lang="en-US" sz="1230" dirty="0">
-                <a:solidFill>
-                  <a:srgbClr val="D2E2DE"/>
-                </a:solidFill>
-                <a:latin typeface="Arial" pitchFamily="34" charset="0"/>
-                <a:ea typeface="Arial" pitchFamily="34" charset="-122"/>
-                <a:cs typeface="Arial" pitchFamily="34" charset="-120"/>
-              </a:rPr>
-              <a:t>• Structured multi-day routines</a:t>
-            </a:r>
-            <a:endParaRPr lang="en-US" sz="1230" dirty="0"/>
-          </a:p>
         </p:txBody>
       </p:sp>
       <p:sp>
@@ -8170,12 +8081,12 @@
         </p:nvSpPr>
         <p:spPr>
           <a:xfrm>
-            <a:off x="1234440" y="5715000"/>
-            <a:ext cx="9738360" cy="429768"/>
+            <a:off x="1143000" y="5760720"/>
+            <a:ext cx="9921240" cy="365760"/>
           </a:xfrm>
           <a:prstGeom prst="roundRect">
             <a:avLst>
-              <a:gd name="adj" fmla="val 17021"/>
+              <a:gd name="adj" fmla="val 20000"/>
             </a:avLst>
           </a:prstGeom>
           <a:solidFill>
@@ -8199,8 +8110,8 @@
         </p:nvSpPr>
         <p:spPr>
           <a:xfrm>
-            <a:off x="1417320" y="5806440"/>
-            <a:ext cx="9372600" cy="210312"/>
+            <a:off x="1335024" y="5843016"/>
+            <a:ext cx="9528048" cy="201168"/>
           </a:xfrm>
           <a:prstGeom prst="rect">
             <a:avLst/>
@@ -8226,7 +8137,7 @@
                 <a:ea typeface="Arial" pitchFamily="34" charset="-122"/>
                 <a:cs typeface="Arial" pitchFamily="34" charset="-120"/>
               </a:rPr>
-              <a:t>TODAY: FREE, PRE-REVENUE PROTOTYPE  ·  FUTURE: EARN WITHOUT SELLING PRIVATE CONVERSATIONS</a:t>
+              <a:t>DEMO UNLOCK ONLY — NO REAL PAYMENT IS PROCESSED  ·  FIGURE IS A FUTURE PROJECTION</a:t>
             </a:r>
             <a:endParaRPr lang="en-US" sz="1000" dirty="0"/>
           </a:p>
@@ -8355,25 +8266,66 @@
         <p:spPr>
           <a:xfrm>
             <a:off x="621792" y="384048"/>
-            <a:ext cx="10972800" cy="365760"/>
-          </a:xfrm>
-          <a:prstGeom prst="rect">
-            <a:avLst/>
-          </a:prstGeom>
-          <a:noFill/>
-          <a:ln/>
-        </p:spPr>
-        <p:txBody>
-          <a:bodyPr wrap="square" lIns="0" tIns="0" rIns="0" bIns="0" rtlCol="0" anchor="ctr">
-            <a:normAutofit/>
-          </a:bodyPr>
-          <a:lstStyle/>
-          <a:p>
-            <a:pPr algn="ctr" indent="0" marL="0">
-              <a:buNone/>
-            </a:pPr>
-            <a:r>
-              <a:rPr lang="en-US" sz="2500" b="1" dirty="0">
+            <a:ext cx="5303520" cy="219456"/>
+          </a:xfrm>
+          <a:prstGeom prst="rect">
+            <a:avLst/>
+          </a:prstGeom>
+          <a:noFill/>
+          <a:ln/>
+        </p:spPr>
+        <p:txBody>
+          <a:bodyPr wrap="square" lIns="0" tIns="0" rIns="0" bIns="0" rtlCol="0" anchor="ctr">
+            <a:normAutofit/>
+          </a:bodyPr>
+          <a:lstStyle/>
+          <a:p>
+            <a:pPr algn="l" indent="0" marL="0">
+              <a:buNone/>
+            </a:pPr>
+            <a:r>
+              <a:rPr lang="en-US" sz="1000" b="1" spc="140" kern="0" dirty="0">
+                <a:solidFill>
+                  <a:srgbClr val="2E7D73"/>
+                </a:solidFill>
+                <a:latin typeface="Arial" pitchFamily="34" charset="0"/>
+                <a:ea typeface="Arial" pitchFamily="34" charset="-122"/>
+                <a:cs typeface="Arial" pitchFamily="34" charset="-120"/>
+              </a:rPr>
+              <a:t>COMPETITION FINANCES</a:t>
+            </a:r>
+            <a:endParaRPr lang="en-US" sz="1000" dirty="0"/>
+          </a:p>
+        </p:txBody>
+      </p:sp>
+      <p:sp>
+        <p:nvSpPr>
+          <p:cNvPr id="3" name="Text 1"/>
+          <p:cNvSpPr/>
+          <p:nvPr/>
+        </p:nvSpPr>
+        <p:spPr>
+          <a:xfrm>
+            <a:off x="621792" y="658368"/>
+            <a:ext cx="10972800" cy="676656"/>
+          </a:xfrm>
+          <a:prstGeom prst="rect">
+            <a:avLst/>
+          </a:prstGeom>
+          <a:noFill/>
+          <a:ln/>
+        </p:spPr>
+        <p:txBody>
+          <a:bodyPr wrap="square" lIns="0" tIns="0" rIns="0" bIns="0" rtlCol="0" anchor="ctr">
+            <a:normAutofit/>
+          </a:bodyPr>
+          <a:lstStyle/>
+          <a:p>
+            <a:pPr algn="l" indent="0" marL="0">
+              <a:buNone/>
+            </a:pPr>
+            <a:r>
+              <a:rPr lang="en-US" sz="2800" b="1" dirty="0">
                 <a:solidFill>
                   <a:srgbClr val="12232B"/>
                 </a:solidFill>
@@ -8381,40 +8333,40 @@
                 <a:ea typeface="Arial" pitchFamily="34" charset="-122"/>
                 <a:cs typeface="Arial" pitchFamily="34" charset="-120"/>
               </a:rPr>
-              <a:t>FINANCIAL STATEMENT</a:t>
-            </a:r>
-            <a:endParaRPr lang="en-US" sz="2500" dirty="0"/>
-          </a:p>
-        </p:txBody>
-      </p:sp>
-      <p:sp>
-        <p:nvSpPr>
-          <p:cNvPr id="3" name="Text 1"/>
-          <p:cNvSpPr/>
-          <p:nvPr/>
-        </p:nvSpPr>
-        <p:spPr>
-          <a:xfrm>
-            <a:off x="1325880" y="932688"/>
-            <a:ext cx="9555480" cy="256032"/>
-          </a:xfrm>
-          <a:prstGeom prst="rect">
-            <a:avLst/>
-          </a:prstGeom>
-          <a:noFill/>
-          <a:ln/>
-        </p:spPr>
-        <p:txBody>
-          <a:bodyPr wrap="square" lIns="0" tIns="0" rIns="0" bIns="0" rtlCol="0" anchor="ctr">
-            <a:normAutofit/>
-          </a:bodyPr>
-          <a:lstStyle/>
-          <a:p>
-            <a:pPr algn="ctr" indent="0" marL="0">
-              <a:buNone/>
-            </a:pPr>
-            <a:r>
-              <a:rPr lang="en-US" sz="1100" i="1" dirty="0">
+              <a:t>Where the projected revenue comes from</a:t>
+            </a:r>
+            <a:endParaRPr lang="en-US" sz="2800" dirty="0"/>
+          </a:p>
+        </p:txBody>
+      </p:sp>
+      <p:sp>
+        <p:nvSpPr>
+          <p:cNvPr id="4" name="Text 2"/>
+          <p:cNvSpPr/>
+          <p:nvPr/>
+        </p:nvSpPr>
+        <p:spPr>
+          <a:xfrm>
+            <a:off x="640080" y="1399032"/>
+            <a:ext cx="10607040" cy="347472"/>
+          </a:xfrm>
+          <a:prstGeom prst="rect">
+            <a:avLst/>
+          </a:prstGeom>
+          <a:noFill/>
+          <a:ln/>
+        </p:spPr>
+        <p:txBody>
+          <a:bodyPr wrap="square" lIns="0" tIns="0" rIns="0" bIns="0" rtlCol="0" anchor="ctr">
+            <a:normAutofit/>
+          </a:bodyPr>
+          <a:lstStyle/>
+          <a:p>
+            <a:pPr algn="l" indent="0" marL="0">
+              <a:buNone/>
+            </a:pPr>
+            <a:r>
+              <a:rPr lang="en-US" sz="1300" dirty="0">
                 <a:solidFill>
                   <a:srgbClr val="68767C"/>
                 </a:solidFill>
@@ -8422,22 +8374,22 @@
                 <a:ea typeface="Arial" pitchFamily="34" charset="-122"/>
                 <a:cs typeface="Arial" pitchFamily="34" charset="-120"/>
               </a:rPr>
-              <a:t>Illustrative/projected competition figures — confirm against verified records before submission.</a:t>
-            </a:r>
-            <a:endParaRPr lang="en-US" sz="1100" dirty="0"/>
-          </a:p>
-        </p:txBody>
-      </p:sp>
-      <p:sp>
-        <p:nvSpPr>
-          <p:cNvPr id="4" name="Shape 2"/>
-          <p:cNvSpPr/>
-          <p:nvPr/>
-        </p:nvSpPr>
-        <p:spPr>
-          <a:xfrm>
-            <a:off x="777240" y="1572768"/>
-            <a:ext cx="2971800" cy="530352"/>
+              <a:t>Figures shown for the competition budget. Verify the records before submission.</a:t>
+            </a:r>
+            <a:endParaRPr lang="en-US" sz="1300" dirty="0"/>
+          </a:p>
+        </p:txBody>
+      </p:sp>
+      <p:sp>
+        <p:nvSpPr>
+          <p:cNvPr id="5" name="Shape 3"/>
+          <p:cNvSpPr/>
+          <p:nvPr/>
+        </p:nvSpPr>
+        <p:spPr>
+          <a:xfrm>
+            <a:off x="658368" y="1901952"/>
+            <a:ext cx="2423160" cy="530352"/>
           </a:xfrm>
           <a:prstGeom prst="rect">
             <a:avLst/>
@@ -8455,14 +8407,14 @@
       </p:sp>
       <p:sp>
         <p:nvSpPr>
-          <p:cNvPr id="5" name="Text 3"/>
-          <p:cNvSpPr/>
-          <p:nvPr/>
-        </p:nvSpPr>
-        <p:spPr>
-          <a:xfrm>
-            <a:off x="868680" y="1627632"/>
-            <a:ext cx="2788920" cy="420624"/>
+          <p:cNvPr id="6" name="Text 4"/>
+          <p:cNvSpPr/>
+          <p:nvPr/>
+        </p:nvSpPr>
+        <p:spPr>
+          <a:xfrm>
+            <a:off x="749808" y="1956816"/>
+            <a:ext cx="2240280" cy="420624"/>
           </a:xfrm>
           <a:prstGeom prst="rect">
             <a:avLst/>
@@ -8488,7 +8440,7 @@
                 <a:ea typeface="Arial" pitchFamily="34" charset="-122"/>
                 <a:cs typeface="Arial" pitchFamily="34" charset="-120"/>
               </a:rPr>
-              <a:t>REVENUE SOURCE</a:t>
+              <a:t>SOURCE</a:t>
             </a:r>
             <a:endParaRPr lang="en-US" sz="1100" dirty="0"/>
           </a:p>
@@ -8496,14 +8448,14 @@
       </p:sp>
       <p:sp>
         <p:nvSpPr>
-          <p:cNvPr id="6" name="Shape 4"/>
-          <p:cNvSpPr/>
-          <p:nvPr/>
-        </p:nvSpPr>
-        <p:spPr>
-          <a:xfrm>
-            <a:off x="3749040" y="1572768"/>
-            <a:ext cx="1874520" cy="530352"/>
+          <p:cNvPr id="7" name="Shape 5"/>
+          <p:cNvSpPr/>
+          <p:nvPr/>
+        </p:nvSpPr>
+        <p:spPr>
+          <a:xfrm>
+            <a:off x="3081528" y="1901952"/>
+            <a:ext cx="2011680" cy="530352"/>
           </a:xfrm>
           <a:prstGeom prst="rect">
             <a:avLst/>
@@ -8521,14 +8473,14 @@
       </p:sp>
       <p:sp>
         <p:nvSpPr>
-          <p:cNvPr id="7" name="Text 5"/>
-          <p:cNvSpPr/>
-          <p:nvPr/>
-        </p:nvSpPr>
-        <p:spPr>
-          <a:xfrm>
-            <a:off x="3840480" y="1627632"/>
-            <a:ext cx="1691640" cy="420624"/>
+          <p:cNvPr id="8" name="Text 6"/>
+          <p:cNvSpPr/>
+          <p:nvPr/>
+        </p:nvSpPr>
+        <p:spPr>
+          <a:xfrm>
+            <a:off x="3172968" y="1956816"/>
+            <a:ext cx="1828800" cy="420624"/>
           </a:xfrm>
           <a:prstGeom prst="rect">
             <a:avLst/>
@@ -8554,7 +8506,7 @@
                 <a:ea typeface="Arial" pitchFamily="34" charset="-122"/>
                 <a:cs typeface="Arial" pitchFamily="34" charset="-120"/>
               </a:rPr>
-              <a:t>UNIT COST (₦)</a:t>
+              <a:t>BASIS</a:t>
             </a:r>
             <a:endParaRPr lang="en-US" sz="1100" dirty="0"/>
           </a:p>
@@ -8562,14 +8514,14 @@
       </p:sp>
       <p:sp>
         <p:nvSpPr>
-          <p:cNvPr id="8" name="Shape 6"/>
-          <p:cNvSpPr/>
-          <p:nvPr/>
-        </p:nvSpPr>
-        <p:spPr>
-          <a:xfrm>
-            <a:off x="5623560" y="1572768"/>
-            <a:ext cx="1508760" cy="530352"/>
+          <p:cNvPr id="9" name="Shape 7"/>
+          <p:cNvSpPr/>
+          <p:nvPr/>
+        </p:nvSpPr>
+        <p:spPr>
+          <a:xfrm>
+            <a:off x="5093208" y="1901952"/>
+            <a:ext cx="3154680" cy="530352"/>
           </a:xfrm>
           <a:prstGeom prst="rect">
             <a:avLst/>
@@ -8587,14 +8539,14 @@
       </p:sp>
       <p:sp>
         <p:nvSpPr>
-          <p:cNvPr id="9" name="Text 7"/>
-          <p:cNvSpPr/>
-          <p:nvPr/>
-        </p:nvSpPr>
-        <p:spPr>
-          <a:xfrm>
-            <a:off x="5715000" y="1627632"/>
-            <a:ext cx="1325880" cy="420624"/>
+          <p:cNvPr id="10" name="Text 8"/>
+          <p:cNvSpPr/>
+          <p:nvPr/>
+        </p:nvSpPr>
+        <p:spPr>
+          <a:xfrm>
+            <a:off x="5184648" y="1956816"/>
+            <a:ext cx="2971800" cy="420624"/>
           </a:xfrm>
           <a:prstGeom prst="rect">
             <a:avLst/>
@@ -8620,7 +8572,7 @@
                 <a:ea typeface="Arial" pitchFamily="34" charset="-122"/>
                 <a:cs typeface="Arial" pitchFamily="34" charset="-120"/>
               </a:rPr>
-              <a:t>UNITS</a:t>
+              <a:t>CALCULATION</a:t>
             </a:r>
             <a:endParaRPr lang="en-US" sz="1100" dirty="0"/>
           </a:p>
@@ -8628,14 +8580,14 @@
       </p:sp>
       <p:sp>
         <p:nvSpPr>
-          <p:cNvPr id="10" name="Shape 8"/>
-          <p:cNvSpPr/>
-          <p:nvPr/>
-        </p:nvSpPr>
-        <p:spPr>
-          <a:xfrm>
-            <a:off x="7132320" y="1572768"/>
-            <a:ext cx="2057400" cy="530352"/>
+          <p:cNvPr id="11" name="Shape 9"/>
+          <p:cNvSpPr/>
+          <p:nvPr/>
+        </p:nvSpPr>
+        <p:spPr>
+          <a:xfrm>
+            <a:off x="8247888" y="1901952"/>
+            <a:ext cx="2240280" cy="530352"/>
           </a:xfrm>
           <a:prstGeom prst="rect">
             <a:avLst/>
@@ -8653,14 +8605,14 @@
       </p:sp>
       <p:sp>
         <p:nvSpPr>
-          <p:cNvPr id="11" name="Text 9"/>
-          <p:cNvSpPr/>
-          <p:nvPr/>
-        </p:nvSpPr>
-        <p:spPr>
-          <a:xfrm>
-            <a:off x="7223760" y="1627632"/>
-            <a:ext cx="1874520" cy="420624"/>
+          <p:cNvPr id="12" name="Text 10"/>
+          <p:cNvSpPr/>
+          <p:nvPr/>
+        </p:nvSpPr>
+        <p:spPr>
+          <a:xfrm>
+            <a:off x="8339328" y="1956816"/>
+            <a:ext cx="2057400" cy="420624"/>
           </a:xfrm>
           <a:prstGeom prst="rect">
             <a:avLst/>
@@ -8694,14 +8646,14 @@
       </p:sp>
       <p:sp>
         <p:nvSpPr>
-          <p:cNvPr id="12" name="Shape 10"/>
-          <p:cNvSpPr/>
-          <p:nvPr/>
-        </p:nvSpPr>
-        <p:spPr>
-          <a:xfrm>
-            <a:off x="777240" y="2103120"/>
-            <a:ext cx="2971800" cy="640080"/>
+          <p:cNvPr id="13" name="Shape 11"/>
+          <p:cNvSpPr/>
+          <p:nvPr/>
+        </p:nvSpPr>
+        <p:spPr>
+          <a:xfrm>
+            <a:off x="658368" y="2432304"/>
+            <a:ext cx="2423160" cy="640080"/>
           </a:xfrm>
           <a:prstGeom prst="rect">
             <a:avLst/>
@@ -8719,32 +8671,32 @@
       </p:sp>
       <p:sp>
         <p:nvSpPr>
-          <p:cNvPr id="13" name="Text 11"/>
-          <p:cNvSpPr/>
-          <p:nvPr/>
-        </p:nvSpPr>
-        <p:spPr>
-          <a:xfrm>
-            <a:off x="868680" y="2157984"/>
-            <a:ext cx="2788920" cy="530352"/>
-          </a:xfrm>
-          <a:prstGeom prst="rect">
-            <a:avLst/>
-          </a:prstGeom>
-          <a:noFill/>
-          <a:ln/>
-        </p:spPr>
-        <p:txBody>
-          <a:bodyPr wrap="square" lIns="0" tIns="0" rIns="0" bIns="0" rtlCol="0" anchor="ctr">
-            <a:normAutofit/>
-          </a:bodyPr>
-          <a:lstStyle/>
-          <a:p>
-            <a:pPr algn="l" indent="0" marL="0">
-              <a:buNone/>
-            </a:pPr>
-            <a:r>
-              <a:rPr lang="en-US" sz="1300" dirty="0">
+          <p:cNvPr id="14" name="Text 12"/>
+          <p:cNvSpPr/>
+          <p:nvPr/>
+        </p:nvSpPr>
+        <p:spPr>
+          <a:xfrm>
+            <a:off x="749808" y="2487168"/>
+            <a:ext cx="2240280" cy="530352"/>
+          </a:xfrm>
+          <a:prstGeom prst="rect">
+            <a:avLst/>
+          </a:prstGeom>
+          <a:noFill/>
+          <a:ln/>
+        </p:spPr>
+        <p:txBody>
+          <a:bodyPr wrap="square" lIns="0" tIns="0" rIns="0" bIns="0" rtlCol="0" anchor="ctr">
+            <a:normAutofit/>
+          </a:bodyPr>
+          <a:lstStyle/>
+          <a:p>
+            <a:pPr algn="l" indent="0" marL="0">
+              <a:buNone/>
+            </a:pPr>
+            <a:r>
+              <a:rPr lang="en-US" sz="1150" dirty="0">
                 <a:solidFill>
                   <a:srgbClr val="12232B"/>
                 </a:solidFill>
@@ -8754,20 +8706,20 @@
               </a:rPr>
               <a:t>Shares</a:t>
             </a:r>
-            <a:endParaRPr lang="en-US" sz="1300" dirty="0"/>
-          </a:p>
-        </p:txBody>
-      </p:sp>
-      <p:sp>
-        <p:nvSpPr>
-          <p:cNvPr id="14" name="Shape 12"/>
-          <p:cNvSpPr/>
-          <p:nvPr/>
-        </p:nvSpPr>
-        <p:spPr>
-          <a:xfrm>
-            <a:off x="3749040" y="2103120"/>
-            <a:ext cx="1874520" cy="640080"/>
+            <a:endParaRPr lang="en-US" sz="1150" dirty="0"/>
+          </a:p>
+        </p:txBody>
+      </p:sp>
+      <p:sp>
+        <p:nvSpPr>
+          <p:cNvPr id="15" name="Shape 13"/>
+          <p:cNvSpPr/>
+          <p:nvPr/>
+        </p:nvSpPr>
+        <p:spPr>
+          <a:xfrm>
+            <a:off x="3081528" y="2432304"/>
+            <a:ext cx="2011680" cy="640080"/>
           </a:xfrm>
           <a:prstGeom prst="rect">
             <a:avLst/>
@@ -8785,32 +8737,32 @@
       </p:sp>
       <p:sp>
         <p:nvSpPr>
-          <p:cNvPr id="15" name="Text 13"/>
-          <p:cNvSpPr/>
-          <p:nvPr/>
-        </p:nvSpPr>
-        <p:spPr>
-          <a:xfrm>
-            <a:off x="3840480" y="2157984"/>
-            <a:ext cx="1691640" cy="530352"/>
-          </a:xfrm>
-          <a:prstGeom prst="rect">
-            <a:avLst/>
-          </a:prstGeom>
-          <a:noFill/>
-          <a:ln/>
-        </p:spPr>
-        <p:txBody>
-          <a:bodyPr wrap="square" lIns="0" tIns="0" rIns="0" bIns="0" rtlCol="0" anchor="ctr">
-            <a:normAutofit/>
-          </a:bodyPr>
-          <a:lstStyle/>
-          <a:p>
-            <a:pPr algn="l" indent="0" marL="0">
-              <a:buNone/>
-            </a:pPr>
-            <a:r>
-              <a:rPr lang="en-US" sz="1300" dirty="0">
+          <p:cNvPr id="16" name="Text 14"/>
+          <p:cNvSpPr/>
+          <p:nvPr/>
+        </p:nvSpPr>
+        <p:spPr>
+          <a:xfrm>
+            <a:off x="3172968" y="2487168"/>
+            <a:ext cx="1828800" cy="530352"/>
+          </a:xfrm>
+          <a:prstGeom prst="rect">
+            <a:avLst/>
+          </a:prstGeom>
+          <a:noFill/>
+          <a:ln/>
+        </p:spPr>
+        <p:txBody>
+          <a:bodyPr wrap="square" lIns="0" tIns="0" rIns="0" bIns="0" rtlCol="0" anchor="ctr">
+            <a:normAutofit/>
+          </a:bodyPr>
+          <a:lstStyle/>
+          <a:p>
+            <a:pPr algn="l" indent="0" marL="0">
+              <a:buNone/>
+            </a:pPr>
+            <a:r>
+              <a:rPr lang="en-US" sz="1150" dirty="0">
                 <a:solidFill>
                   <a:srgbClr val="12232B"/>
                 </a:solidFill>
@@ -8818,22 +8770,22 @@
                 <a:ea typeface="Arial" pitchFamily="34" charset="-122"/>
                 <a:cs typeface="Arial" pitchFamily="34" charset="-120"/>
               </a:rPr>
-              <a:t>500</a:t>
-            </a:r>
-            <a:endParaRPr lang="en-US" sz="1300" dirty="0"/>
-          </a:p>
-        </p:txBody>
-      </p:sp>
-      <p:sp>
-        <p:nvSpPr>
-          <p:cNvPr id="16" name="Shape 14"/>
-          <p:cNvSpPr/>
-          <p:nvPr/>
-        </p:nvSpPr>
-        <p:spPr>
-          <a:xfrm>
-            <a:off x="5623560" y="2103120"/>
-            <a:ext cx="1508760" cy="640080"/>
+              <a:t>₦500 each</a:t>
+            </a:r>
+            <a:endParaRPr lang="en-US" sz="1150" dirty="0"/>
+          </a:p>
+        </p:txBody>
+      </p:sp>
+      <p:sp>
+        <p:nvSpPr>
+          <p:cNvPr id="17" name="Shape 15"/>
+          <p:cNvSpPr/>
+          <p:nvPr/>
+        </p:nvSpPr>
+        <p:spPr>
+          <a:xfrm>
+            <a:off x="5093208" y="2432304"/>
+            <a:ext cx="3154680" cy="640080"/>
           </a:xfrm>
           <a:prstGeom prst="rect">
             <a:avLst/>
@@ -8851,32 +8803,32 @@
       </p:sp>
       <p:sp>
         <p:nvSpPr>
-          <p:cNvPr id="17" name="Text 15"/>
-          <p:cNvSpPr/>
-          <p:nvPr/>
-        </p:nvSpPr>
-        <p:spPr>
-          <a:xfrm>
-            <a:off x="5715000" y="2157984"/>
-            <a:ext cx="1325880" cy="530352"/>
-          </a:xfrm>
-          <a:prstGeom prst="rect">
-            <a:avLst/>
-          </a:prstGeom>
-          <a:noFill/>
-          <a:ln/>
-        </p:spPr>
-        <p:txBody>
-          <a:bodyPr wrap="square" lIns="0" tIns="0" rIns="0" bIns="0" rtlCol="0" anchor="ctr">
-            <a:normAutofit/>
-          </a:bodyPr>
-          <a:lstStyle/>
-          <a:p>
-            <a:pPr algn="l" indent="0" marL="0">
-              <a:buNone/>
-            </a:pPr>
-            <a:r>
-              <a:rPr lang="en-US" sz="1300" dirty="0">
+          <p:cNvPr id="18" name="Text 16"/>
+          <p:cNvSpPr/>
+          <p:nvPr/>
+        </p:nvSpPr>
+        <p:spPr>
+          <a:xfrm>
+            <a:off x="5184648" y="2487168"/>
+            <a:ext cx="2971800" cy="530352"/>
+          </a:xfrm>
+          <a:prstGeom prst="rect">
+            <a:avLst/>
+          </a:prstGeom>
+          <a:noFill/>
+          <a:ln/>
+        </p:spPr>
+        <p:txBody>
+          <a:bodyPr wrap="square" lIns="0" tIns="0" rIns="0" bIns="0" rtlCol="0" anchor="ctr">
+            <a:normAutofit/>
+          </a:bodyPr>
+          <a:lstStyle/>
+          <a:p>
+            <a:pPr algn="l" indent="0" marL="0">
+              <a:buNone/>
+            </a:pPr>
+            <a:r>
+              <a:rPr lang="en-US" sz="1150" dirty="0">
                 <a:solidFill>
                   <a:srgbClr val="12232B"/>
                 </a:solidFill>
@@ -8884,22 +8836,22 @@
                 <a:ea typeface="Arial" pitchFamily="34" charset="-122"/>
                 <a:cs typeface="Arial" pitchFamily="34" charset="-120"/>
               </a:rPr>
-              <a:t>100</a:t>
-            </a:r>
-            <a:endParaRPr lang="en-US" sz="1300" dirty="0"/>
-          </a:p>
-        </p:txBody>
-      </p:sp>
-      <p:sp>
-        <p:nvSpPr>
-          <p:cNvPr id="18" name="Shape 16"/>
-          <p:cNvSpPr/>
-          <p:nvPr/>
-        </p:nvSpPr>
-        <p:spPr>
-          <a:xfrm>
-            <a:off x="7132320" y="2103120"/>
-            <a:ext cx="2057400" cy="640080"/>
+              <a:t>₦500 × 100</a:t>
+            </a:r>
+            <a:endParaRPr lang="en-US" sz="1150" dirty="0"/>
+          </a:p>
+        </p:txBody>
+      </p:sp>
+      <p:sp>
+        <p:nvSpPr>
+          <p:cNvPr id="19" name="Shape 17"/>
+          <p:cNvSpPr/>
+          <p:nvPr/>
+        </p:nvSpPr>
+        <p:spPr>
+          <a:xfrm>
+            <a:off x="8247888" y="2432304"/>
+            <a:ext cx="2240280" cy="640080"/>
           </a:xfrm>
           <a:prstGeom prst="rect">
             <a:avLst/>
@@ -8917,14 +8869,14 @@
       </p:sp>
       <p:sp>
         <p:nvSpPr>
-          <p:cNvPr id="19" name="Text 17"/>
-          <p:cNvSpPr/>
-          <p:nvPr/>
-        </p:nvSpPr>
-        <p:spPr>
-          <a:xfrm>
-            <a:off x="7223760" y="2157984"/>
-            <a:ext cx="1874520" cy="530352"/>
+          <p:cNvPr id="20" name="Text 18"/>
+          <p:cNvSpPr/>
+          <p:nvPr/>
+        </p:nvSpPr>
+        <p:spPr>
+          <a:xfrm>
+            <a:off x="8339328" y="2487168"/>
+            <a:ext cx="2057400" cy="530352"/>
           </a:xfrm>
           <a:prstGeom prst="rect">
             <a:avLst/>
@@ -8942,7 +8894,7 @@
               <a:buNone/>
             </a:pPr>
             <a:r>
-              <a:rPr lang="en-US" sz="1300" dirty="0">
+              <a:rPr lang="en-US" sz="1150" dirty="0">
                 <a:solidFill>
                   <a:srgbClr val="12232B"/>
                 </a:solidFill>
@@ -8952,20 +8904,20 @@
               </a:rPr>
               <a:t>50,000</a:t>
             </a:r>
-            <a:endParaRPr lang="en-US" sz="1300" dirty="0"/>
-          </a:p>
-        </p:txBody>
-      </p:sp>
-      <p:sp>
-        <p:nvSpPr>
-          <p:cNvPr id="20" name="Shape 18"/>
-          <p:cNvSpPr/>
-          <p:nvPr/>
-        </p:nvSpPr>
-        <p:spPr>
-          <a:xfrm>
-            <a:off x="777240" y="2743200"/>
-            <a:ext cx="2971800" cy="640080"/>
+            <a:endParaRPr lang="en-US" sz="1150" dirty="0"/>
+          </a:p>
+        </p:txBody>
+      </p:sp>
+      <p:sp>
+        <p:nvSpPr>
+          <p:cNvPr id="21" name="Shape 19"/>
+          <p:cNvSpPr/>
+          <p:nvPr/>
+        </p:nvSpPr>
+        <p:spPr>
+          <a:xfrm>
+            <a:off x="658368" y="3072384"/>
+            <a:ext cx="2423160" cy="640080"/>
           </a:xfrm>
           <a:prstGeom prst="rect">
             <a:avLst/>
@@ -8983,32 +8935,32 @@
       </p:sp>
       <p:sp>
         <p:nvSpPr>
-          <p:cNvPr id="21" name="Text 19"/>
-          <p:cNvSpPr/>
-          <p:nvPr/>
-        </p:nvSpPr>
-        <p:spPr>
-          <a:xfrm>
-            <a:off x="868680" y="2798064"/>
-            <a:ext cx="2788920" cy="530352"/>
-          </a:xfrm>
-          <a:prstGeom prst="rect">
-            <a:avLst/>
-          </a:prstGeom>
-          <a:noFill/>
-          <a:ln/>
-        </p:spPr>
-        <p:txBody>
-          <a:bodyPr wrap="square" lIns="0" tIns="0" rIns="0" bIns="0" rtlCol="0" anchor="ctr">
-            <a:normAutofit/>
-          </a:bodyPr>
-          <a:lstStyle/>
-          <a:p>
-            <a:pPr algn="l" indent="0" marL="0">
-              <a:buNone/>
-            </a:pPr>
-            <a:r>
-              <a:rPr lang="en-US" sz="1300" dirty="0">
+          <p:cNvPr id="22" name="Text 20"/>
+          <p:cNvSpPr/>
+          <p:nvPr/>
+        </p:nvSpPr>
+        <p:spPr>
+          <a:xfrm>
+            <a:off x="749808" y="3127248"/>
+            <a:ext cx="2240280" cy="530352"/>
+          </a:xfrm>
+          <a:prstGeom prst="rect">
+            <a:avLst/>
+          </a:prstGeom>
+          <a:noFill/>
+          <a:ln/>
+        </p:spPr>
+        <p:txBody>
+          <a:bodyPr wrap="square" lIns="0" tIns="0" rIns="0" bIns="0" rtlCol="0" anchor="ctr">
+            <a:normAutofit/>
+          </a:bodyPr>
+          <a:lstStyle/>
+          <a:p>
+            <a:pPr algn="l" indent="0" marL="0">
+              <a:buNone/>
+            </a:pPr>
+            <a:r>
+              <a:rPr lang="en-US" sz="1150" dirty="0">
                 <a:solidFill>
                   <a:srgbClr val="12232B"/>
                 </a:solidFill>
@@ -9018,20 +8970,20 @@
               </a:rPr>
               <a:t>Sponsorship</a:t>
             </a:r>
-            <a:endParaRPr lang="en-US" sz="1300" dirty="0"/>
-          </a:p>
-        </p:txBody>
-      </p:sp>
-      <p:sp>
-        <p:nvSpPr>
-          <p:cNvPr id="22" name="Shape 20"/>
-          <p:cNvSpPr/>
-          <p:nvPr/>
-        </p:nvSpPr>
-        <p:spPr>
-          <a:xfrm>
-            <a:off x="3749040" y="2743200"/>
-            <a:ext cx="1874520" cy="640080"/>
+            <a:endParaRPr lang="en-US" sz="1150" dirty="0"/>
+          </a:p>
+        </p:txBody>
+      </p:sp>
+      <p:sp>
+        <p:nvSpPr>
+          <p:cNvPr id="23" name="Shape 21"/>
+          <p:cNvSpPr/>
+          <p:nvPr/>
+        </p:nvSpPr>
+        <p:spPr>
+          <a:xfrm>
+            <a:off x="3081528" y="3072384"/>
+            <a:ext cx="2011680" cy="640080"/>
           </a:xfrm>
           <a:prstGeom prst="rect">
             <a:avLst/>
@@ -9049,32 +9001,32 @@
       </p:sp>
       <p:sp>
         <p:nvSpPr>
-          <p:cNvPr id="23" name="Text 21"/>
-          <p:cNvSpPr/>
-          <p:nvPr/>
-        </p:nvSpPr>
-        <p:spPr>
-          <a:xfrm>
-            <a:off x="3840480" y="2798064"/>
-            <a:ext cx="1691640" cy="530352"/>
-          </a:xfrm>
-          <a:prstGeom prst="rect">
-            <a:avLst/>
-          </a:prstGeom>
-          <a:noFill/>
-          <a:ln/>
-        </p:spPr>
-        <p:txBody>
-          <a:bodyPr wrap="square" lIns="0" tIns="0" rIns="0" bIns="0" rtlCol="0" anchor="ctr">
-            <a:normAutofit/>
-          </a:bodyPr>
-          <a:lstStyle/>
-          <a:p>
-            <a:pPr algn="l" indent="0" marL="0">
-              <a:buNone/>
-            </a:pPr>
-            <a:r>
-              <a:rPr lang="en-US" sz="1300" dirty="0">
+          <p:cNvPr id="24" name="Text 22"/>
+          <p:cNvSpPr/>
+          <p:nvPr/>
+        </p:nvSpPr>
+        <p:spPr>
+          <a:xfrm>
+            <a:off x="3172968" y="3127248"/>
+            <a:ext cx="1828800" cy="530352"/>
+          </a:xfrm>
+          <a:prstGeom prst="rect">
+            <a:avLst/>
+          </a:prstGeom>
+          <a:noFill/>
+          <a:ln/>
+        </p:spPr>
+        <p:txBody>
+          <a:bodyPr wrap="square" lIns="0" tIns="0" rIns="0" bIns="0" rtlCol="0" anchor="ctr">
+            <a:normAutofit/>
+          </a:bodyPr>
+          <a:lstStyle/>
+          <a:p>
+            <a:pPr algn="l" indent="0" marL="0">
+              <a:buNone/>
+            </a:pPr>
+            <a:r>
+              <a:rPr lang="en-US" sz="1150" dirty="0">
                 <a:solidFill>
                   <a:srgbClr val="12232B"/>
                 </a:solidFill>
@@ -9082,22 +9034,22 @@
                 <a:ea typeface="Arial" pitchFamily="34" charset="-122"/>
                 <a:cs typeface="Arial" pitchFamily="34" charset="-120"/>
               </a:rPr>
-              <a:t>—</a:t>
-            </a:r>
-            <a:endParaRPr lang="en-US" sz="1300" dirty="0"/>
-          </a:p>
-        </p:txBody>
-      </p:sp>
-      <p:sp>
-        <p:nvSpPr>
-          <p:cNvPr id="24" name="Shape 22"/>
-          <p:cNvSpPr/>
-          <p:nvPr/>
-        </p:nvSpPr>
-        <p:spPr>
-          <a:xfrm>
-            <a:off x="5623560" y="2743200"/>
-            <a:ext cx="1508760" cy="640080"/>
+              <a:t>1 sponsor</a:t>
+            </a:r>
+            <a:endParaRPr lang="en-US" sz="1150" dirty="0"/>
+          </a:p>
+        </p:txBody>
+      </p:sp>
+      <p:sp>
+        <p:nvSpPr>
+          <p:cNvPr id="25" name="Shape 23"/>
+          <p:cNvSpPr/>
+          <p:nvPr/>
+        </p:nvSpPr>
+        <p:spPr>
+          <a:xfrm>
+            <a:off x="5093208" y="3072384"/>
+            <a:ext cx="3154680" cy="640080"/>
           </a:xfrm>
           <a:prstGeom prst="rect">
             <a:avLst/>
@@ -9115,32 +9067,32 @@
       </p:sp>
       <p:sp>
         <p:nvSpPr>
-          <p:cNvPr id="25" name="Text 23"/>
-          <p:cNvSpPr/>
-          <p:nvPr/>
-        </p:nvSpPr>
-        <p:spPr>
-          <a:xfrm>
-            <a:off x="5715000" y="2798064"/>
-            <a:ext cx="1325880" cy="530352"/>
-          </a:xfrm>
-          <a:prstGeom prst="rect">
-            <a:avLst/>
-          </a:prstGeom>
-          <a:noFill/>
-          <a:ln/>
-        </p:spPr>
-        <p:txBody>
-          <a:bodyPr wrap="square" lIns="0" tIns="0" rIns="0" bIns="0" rtlCol="0" anchor="ctr">
-            <a:normAutofit/>
-          </a:bodyPr>
-          <a:lstStyle/>
-          <a:p>
-            <a:pPr algn="l" indent="0" marL="0">
-              <a:buNone/>
-            </a:pPr>
-            <a:r>
-              <a:rPr lang="en-US" sz="1300" dirty="0">
+          <p:cNvPr id="26" name="Text 24"/>
+          <p:cNvSpPr/>
+          <p:nvPr/>
+        </p:nvSpPr>
+        <p:spPr>
+          <a:xfrm>
+            <a:off x="5184648" y="3127248"/>
+            <a:ext cx="2971800" cy="530352"/>
+          </a:xfrm>
+          <a:prstGeom prst="rect">
+            <a:avLst/>
+          </a:prstGeom>
+          <a:noFill/>
+          <a:ln/>
+        </p:spPr>
+        <p:txBody>
+          <a:bodyPr wrap="square" lIns="0" tIns="0" rIns="0" bIns="0" rtlCol="0" anchor="ctr">
+            <a:normAutofit/>
+          </a:bodyPr>
+          <a:lstStyle/>
+          <a:p>
+            <a:pPr algn="l" indent="0" marL="0">
+              <a:buNone/>
+            </a:pPr>
+            <a:r>
+              <a:rPr lang="en-US" sz="1150" dirty="0">
                 <a:solidFill>
                   <a:srgbClr val="12232B"/>
                 </a:solidFill>
@@ -9148,22 +9100,22 @@
                 <a:ea typeface="Arial" pitchFamily="34" charset="-122"/>
                 <a:cs typeface="Arial" pitchFamily="34" charset="-120"/>
               </a:rPr>
-              <a:t>—</a:t>
-            </a:r>
-            <a:endParaRPr lang="en-US" sz="1300" dirty="0"/>
-          </a:p>
-        </p:txBody>
-      </p:sp>
-      <p:sp>
-        <p:nvSpPr>
-          <p:cNvPr id="26" name="Shape 24"/>
-          <p:cNvSpPr/>
-          <p:nvPr/>
-        </p:nvSpPr>
-        <p:spPr>
-          <a:xfrm>
-            <a:off x="7132320" y="2743200"/>
-            <a:ext cx="2057400" cy="640080"/>
+              <a:t>1 × ₦200,000</a:t>
+            </a:r>
+            <a:endParaRPr lang="en-US" sz="1150" dirty="0"/>
+          </a:p>
+        </p:txBody>
+      </p:sp>
+      <p:sp>
+        <p:nvSpPr>
+          <p:cNvPr id="27" name="Shape 25"/>
+          <p:cNvSpPr/>
+          <p:nvPr/>
+        </p:nvSpPr>
+        <p:spPr>
+          <a:xfrm>
+            <a:off x="8247888" y="3072384"/>
+            <a:ext cx="2240280" cy="640080"/>
           </a:xfrm>
           <a:prstGeom prst="rect">
             <a:avLst/>
@@ -9181,14 +9133,14 @@
       </p:sp>
       <p:sp>
         <p:nvSpPr>
-          <p:cNvPr id="27" name="Text 25"/>
-          <p:cNvSpPr/>
-          <p:nvPr/>
-        </p:nvSpPr>
-        <p:spPr>
-          <a:xfrm>
-            <a:off x="7223760" y="2798064"/>
-            <a:ext cx="1874520" cy="530352"/>
+          <p:cNvPr id="28" name="Text 26"/>
+          <p:cNvSpPr/>
+          <p:nvPr/>
+        </p:nvSpPr>
+        <p:spPr>
+          <a:xfrm>
+            <a:off x="8339328" y="3127248"/>
+            <a:ext cx="2057400" cy="530352"/>
           </a:xfrm>
           <a:prstGeom prst="rect">
             <a:avLst/>
@@ -9206,7 +9158,7 @@
               <a:buNone/>
             </a:pPr>
             <a:r>
-              <a:rPr lang="en-US" sz="1300" dirty="0">
+              <a:rPr lang="en-US" sz="1150" dirty="0">
                 <a:solidFill>
                   <a:srgbClr val="12232B"/>
                 </a:solidFill>
@@ -9216,20 +9168,20 @@
               </a:rPr>
               <a:t>200,000</a:t>
             </a:r>
-            <a:endParaRPr lang="en-US" sz="1300" dirty="0"/>
-          </a:p>
-        </p:txBody>
-      </p:sp>
-      <p:sp>
-        <p:nvSpPr>
-          <p:cNvPr id="28" name="Shape 26"/>
-          <p:cNvSpPr/>
-          <p:nvPr/>
-        </p:nvSpPr>
-        <p:spPr>
-          <a:xfrm>
-            <a:off x="777240" y="3383280"/>
-            <a:ext cx="2971800" cy="640080"/>
+            <a:endParaRPr lang="en-US" sz="1150" dirty="0"/>
+          </a:p>
+        </p:txBody>
+      </p:sp>
+      <p:sp>
+        <p:nvSpPr>
+          <p:cNvPr id="29" name="Shape 27"/>
+          <p:cNvSpPr/>
+          <p:nvPr/>
+        </p:nvSpPr>
+        <p:spPr>
+          <a:xfrm>
+            <a:off x="658368" y="3712464"/>
+            <a:ext cx="2423160" cy="640080"/>
           </a:xfrm>
           <a:prstGeom prst="rect">
             <a:avLst/>
@@ -9247,32 +9199,32 @@
       </p:sp>
       <p:sp>
         <p:nvSpPr>
-          <p:cNvPr id="29" name="Text 27"/>
-          <p:cNvSpPr/>
-          <p:nvPr/>
-        </p:nvSpPr>
-        <p:spPr>
-          <a:xfrm>
-            <a:off x="868680" y="3438144"/>
-            <a:ext cx="2788920" cy="530352"/>
-          </a:xfrm>
-          <a:prstGeom prst="rect">
-            <a:avLst/>
-          </a:prstGeom>
-          <a:noFill/>
-          <a:ln/>
-        </p:spPr>
-        <p:txBody>
-          <a:bodyPr wrap="square" lIns="0" tIns="0" rIns="0" bIns="0" rtlCol="0" anchor="ctr">
-            <a:normAutofit/>
-          </a:bodyPr>
-          <a:lstStyle/>
-          <a:p>
-            <a:pPr algn="l" indent="0" marL="0">
-              <a:buNone/>
-            </a:pPr>
-            <a:r>
-              <a:rPr lang="en-US" sz="1300" dirty="0">
+          <p:cNvPr id="30" name="Text 28"/>
+          <p:cNvSpPr/>
+          <p:nvPr/>
+        </p:nvSpPr>
+        <p:spPr>
+          <a:xfrm>
+            <a:off x="749808" y="3767328"/>
+            <a:ext cx="2240280" cy="530352"/>
+          </a:xfrm>
+          <a:prstGeom prst="rect">
+            <a:avLst/>
+          </a:prstGeom>
+          <a:noFill/>
+          <a:ln/>
+        </p:spPr>
+        <p:txBody>
+          <a:bodyPr wrap="square" lIns="0" tIns="0" rIns="0" bIns="0" rtlCol="0" anchor="ctr">
+            <a:normAutofit/>
+          </a:bodyPr>
+          <a:lstStyle/>
+          <a:p>
+            <a:pPr algn="l" indent="0" marL="0">
+              <a:buNone/>
+            </a:pPr>
+            <a:r>
+              <a:rPr lang="en-US" sz="1150" dirty="0">
                 <a:solidFill>
                   <a:srgbClr val="12232B"/>
                 </a:solidFill>
@@ -9282,20 +9234,20 @@
               </a:rPr>
               <a:t>Sales of confectioneries</a:t>
             </a:r>
-            <a:endParaRPr lang="en-US" sz="1300" dirty="0"/>
-          </a:p>
-        </p:txBody>
-      </p:sp>
-      <p:sp>
-        <p:nvSpPr>
-          <p:cNvPr id="30" name="Shape 28"/>
-          <p:cNvSpPr/>
-          <p:nvPr/>
-        </p:nvSpPr>
-        <p:spPr>
-          <a:xfrm>
-            <a:off x="3749040" y="3383280"/>
-            <a:ext cx="1874520" cy="640080"/>
+            <a:endParaRPr lang="en-US" sz="1150" dirty="0"/>
+          </a:p>
+        </p:txBody>
+      </p:sp>
+      <p:sp>
+        <p:nvSpPr>
+          <p:cNvPr id="31" name="Shape 29"/>
+          <p:cNvSpPr/>
+          <p:nvPr/>
+        </p:nvSpPr>
+        <p:spPr>
+          <a:xfrm>
+            <a:off x="3081528" y="3712464"/>
+            <a:ext cx="2011680" cy="640080"/>
           </a:xfrm>
           <a:prstGeom prst="rect">
             <a:avLst/>
@@ -9313,32 +9265,32 @@
       </p:sp>
       <p:sp>
         <p:nvSpPr>
-          <p:cNvPr id="31" name="Text 29"/>
-          <p:cNvSpPr/>
-          <p:nvPr/>
-        </p:nvSpPr>
-        <p:spPr>
-          <a:xfrm>
-            <a:off x="3840480" y="3438144"/>
-            <a:ext cx="1691640" cy="530352"/>
-          </a:xfrm>
-          <a:prstGeom prst="rect">
-            <a:avLst/>
-          </a:prstGeom>
-          <a:noFill/>
-          <a:ln/>
-        </p:spPr>
-        <p:txBody>
-          <a:bodyPr wrap="square" lIns="0" tIns="0" rIns="0" bIns="0" rtlCol="0" anchor="ctr">
-            <a:normAutofit/>
-          </a:bodyPr>
-          <a:lstStyle/>
-          <a:p>
-            <a:pPr algn="l" indent="0" marL="0">
-              <a:buNone/>
-            </a:pPr>
-            <a:r>
-              <a:rPr lang="en-US" sz="1300" dirty="0">
+          <p:cNvPr id="32" name="Text 30"/>
+          <p:cNvSpPr/>
+          <p:nvPr/>
+        </p:nvSpPr>
+        <p:spPr>
+          <a:xfrm>
+            <a:off x="3172968" y="3767328"/>
+            <a:ext cx="1828800" cy="530352"/>
+          </a:xfrm>
+          <a:prstGeom prst="rect">
+            <a:avLst/>
+          </a:prstGeom>
+          <a:noFill/>
+          <a:ln/>
+        </p:spPr>
+        <p:txBody>
+          <a:bodyPr wrap="square" lIns="0" tIns="0" rIns="0" bIns="0" rtlCol="0" anchor="ctr">
+            <a:normAutofit/>
+          </a:bodyPr>
+          <a:lstStyle/>
+          <a:p>
+            <a:pPr algn="l" indent="0" marL="0">
+              <a:buNone/>
+            </a:pPr>
+            <a:r>
+              <a:rPr lang="en-US" sz="1150" dirty="0">
                 <a:solidFill>
                   <a:srgbClr val="12232B"/>
                 </a:solidFill>
@@ -9346,22 +9298,22 @@
                 <a:ea typeface="Arial" pitchFamily="34" charset="-122"/>
                 <a:cs typeface="Arial" pitchFamily="34" charset="-120"/>
               </a:rPr>
-              <a:t>100</a:t>
-            </a:r>
-            <a:endParaRPr lang="en-US" sz="1300" dirty="0"/>
-          </a:p>
-        </p:txBody>
-      </p:sp>
-      <p:sp>
-        <p:nvSpPr>
-          <p:cNvPr id="32" name="Shape 30"/>
-          <p:cNvSpPr/>
-          <p:nvPr/>
-        </p:nvSpPr>
-        <p:spPr>
-          <a:xfrm>
-            <a:off x="5623560" y="3383280"/>
-            <a:ext cx="1508760" cy="640080"/>
+              <a:t>₦100 each</a:t>
+            </a:r>
+            <a:endParaRPr lang="en-US" sz="1150" dirty="0"/>
+          </a:p>
+        </p:txBody>
+      </p:sp>
+      <p:sp>
+        <p:nvSpPr>
+          <p:cNvPr id="33" name="Shape 31"/>
+          <p:cNvSpPr/>
+          <p:nvPr/>
+        </p:nvSpPr>
+        <p:spPr>
+          <a:xfrm>
+            <a:off x="5093208" y="3712464"/>
+            <a:ext cx="3154680" cy="640080"/>
           </a:xfrm>
           <a:prstGeom prst="rect">
             <a:avLst/>
@@ -9379,32 +9331,32 @@
       </p:sp>
       <p:sp>
         <p:nvSpPr>
-          <p:cNvPr id="33" name="Text 31"/>
-          <p:cNvSpPr/>
-          <p:nvPr/>
-        </p:nvSpPr>
-        <p:spPr>
-          <a:xfrm>
-            <a:off x="5715000" y="3438144"/>
-            <a:ext cx="1325880" cy="530352"/>
-          </a:xfrm>
-          <a:prstGeom prst="rect">
-            <a:avLst/>
-          </a:prstGeom>
-          <a:noFill/>
-          <a:ln/>
-        </p:spPr>
-        <p:txBody>
-          <a:bodyPr wrap="square" lIns="0" tIns="0" rIns="0" bIns="0" rtlCol="0" anchor="ctr">
-            <a:normAutofit/>
-          </a:bodyPr>
-          <a:lstStyle/>
-          <a:p>
-            <a:pPr algn="l" indent="0" marL="0">
-              <a:buNone/>
-            </a:pPr>
-            <a:r>
-              <a:rPr lang="en-US" sz="1300" dirty="0">
+          <p:cNvPr id="34" name="Text 32"/>
+          <p:cNvSpPr/>
+          <p:nvPr/>
+        </p:nvSpPr>
+        <p:spPr>
+          <a:xfrm>
+            <a:off x="5184648" y="3767328"/>
+            <a:ext cx="2971800" cy="530352"/>
+          </a:xfrm>
+          <a:prstGeom prst="rect">
+            <a:avLst/>
+          </a:prstGeom>
+          <a:noFill/>
+          <a:ln/>
+        </p:spPr>
+        <p:txBody>
+          <a:bodyPr wrap="square" lIns="0" tIns="0" rIns="0" bIns="0" rtlCol="0" anchor="ctr">
+            <a:normAutofit/>
+          </a:bodyPr>
+          <a:lstStyle/>
+          <a:p>
+            <a:pPr algn="l" indent="0" marL="0">
+              <a:buNone/>
+            </a:pPr>
+            <a:r>
+              <a:rPr lang="en-US" sz="1150" dirty="0">
                 <a:solidFill>
                   <a:srgbClr val="12232B"/>
                 </a:solidFill>
@@ -9412,22 +9364,22 @@
                 <a:ea typeface="Arial" pitchFamily="34" charset="-122"/>
                 <a:cs typeface="Arial" pitchFamily="34" charset="-120"/>
               </a:rPr>
-              <a:t>500</a:t>
-            </a:r>
-            <a:endParaRPr lang="en-US" sz="1300" dirty="0"/>
-          </a:p>
-        </p:txBody>
-      </p:sp>
-      <p:sp>
-        <p:nvSpPr>
-          <p:cNvPr id="34" name="Shape 32"/>
-          <p:cNvSpPr/>
-          <p:nvPr/>
-        </p:nvSpPr>
-        <p:spPr>
-          <a:xfrm>
-            <a:off x="7132320" y="3383280"/>
-            <a:ext cx="2057400" cy="640080"/>
+              <a:t>₦100 × 500</a:t>
+            </a:r>
+            <a:endParaRPr lang="en-US" sz="1150" dirty="0"/>
+          </a:p>
+        </p:txBody>
+      </p:sp>
+      <p:sp>
+        <p:nvSpPr>
+          <p:cNvPr id="35" name="Shape 33"/>
+          <p:cNvSpPr/>
+          <p:nvPr/>
+        </p:nvSpPr>
+        <p:spPr>
+          <a:xfrm>
+            <a:off x="8247888" y="3712464"/>
+            <a:ext cx="2240280" cy="640080"/>
           </a:xfrm>
           <a:prstGeom prst="rect">
             <a:avLst/>
@@ -9445,14 +9397,14 @@
       </p:sp>
       <p:sp>
         <p:nvSpPr>
-          <p:cNvPr id="35" name="Text 33"/>
-          <p:cNvSpPr/>
-          <p:nvPr/>
-        </p:nvSpPr>
-        <p:spPr>
-          <a:xfrm>
-            <a:off x="7223760" y="3438144"/>
-            <a:ext cx="1874520" cy="530352"/>
+          <p:cNvPr id="36" name="Text 34"/>
+          <p:cNvSpPr/>
+          <p:nvPr/>
+        </p:nvSpPr>
+        <p:spPr>
+          <a:xfrm>
+            <a:off x="8339328" y="3767328"/>
+            <a:ext cx="2057400" cy="530352"/>
           </a:xfrm>
           <a:prstGeom prst="rect">
             <a:avLst/>
@@ -9470,7 +9422,7 @@
               <a:buNone/>
             </a:pPr>
             <a:r>
-              <a:rPr lang="en-US" sz="1300" dirty="0">
+              <a:rPr lang="en-US" sz="1150" dirty="0">
                 <a:solidFill>
                   <a:srgbClr val="12232B"/>
                 </a:solidFill>
@@ -9480,20 +9432,20 @@
               </a:rPr>
               <a:t>50,000</a:t>
             </a:r>
-            <a:endParaRPr lang="en-US" sz="1300" dirty="0"/>
-          </a:p>
-        </p:txBody>
-      </p:sp>
-      <p:sp>
-        <p:nvSpPr>
-          <p:cNvPr id="36" name="Shape 34"/>
-          <p:cNvSpPr/>
-          <p:nvPr/>
-        </p:nvSpPr>
-        <p:spPr>
-          <a:xfrm>
-            <a:off x="777240" y="4023360"/>
-            <a:ext cx="2971800" cy="640080"/>
+            <a:endParaRPr lang="en-US" sz="1150" dirty="0"/>
+          </a:p>
+        </p:txBody>
+      </p:sp>
+      <p:sp>
+        <p:nvSpPr>
+          <p:cNvPr id="37" name="Shape 35"/>
+          <p:cNvSpPr/>
+          <p:nvPr/>
+        </p:nvSpPr>
+        <p:spPr>
+          <a:xfrm>
+            <a:off x="658368" y="4352544"/>
+            <a:ext cx="2423160" cy="640080"/>
           </a:xfrm>
           <a:prstGeom prst="rect">
             <a:avLst/>
@@ -9511,32 +9463,32 @@
       </p:sp>
       <p:sp>
         <p:nvSpPr>
-          <p:cNvPr id="37" name="Text 35"/>
-          <p:cNvSpPr/>
-          <p:nvPr/>
-        </p:nvSpPr>
-        <p:spPr>
-          <a:xfrm>
-            <a:off x="868680" y="4078224"/>
-            <a:ext cx="2788920" cy="530352"/>
-          </a:xfrm>
-          <a:prstGeom prst="rect">
-            <a:avLst/>
-          </a:prstGeom>
-          <a:noFill/>
-          <a:ln/>
-        </p:spPr>
-        <p:txBody>
-          <a:bodyPr wrap="square" lIns="0" tIns="0" rIns="0" bIns="0" rtlCol="0" anchor="ctr">
-            <a:normAutofit/>
-          </a:bodyPr>
-          <a:lstStyle/>
-          <a:p>
-            <a:pPr algn="l" indent="0" marL="0">
-              <a:buNone/>
-            </a:pPr>
-            <a:r>
-              <a:rPr lang="en-US" sz="1300" b="1" dirty="0">
+          <p:cNvPr id="38" name="Text 36"/>
+          <p:cNvSpPr/>
+          <p:nvPr/>
+        </p:nvSpPr>
+        <p:spPr>
+          <a:xfrm>
+            <a:off x="749808" y="4407408"/>
+            <a:ext cx="2240280" cy="530352"/>
+          </a:xfrm>
+          <a:prstGeom prst="rect">
+            <a:avLst/>
+          </a:prstGeom>
+          <a:noFill/>
+          <a:ln/>
+        </p:spPr>
+        <p:txBody>
+          <a:bodyPr wrap="square" lIns="0" tIns="0" rIns="0" bIns="0" rtlCol="0" anchor="ctr">
+            <a:normAutofit/>
+          </a:bodyPr>
+          <a:lstStyle/>
+          <a:p>
+            <a:pPr algn="l" indent="0" marL="0">
+              <a:buNone/>
+            </a:pPr>
+            <a:r>
+              <a:rPr lang="en-US" sz="1200" b="1" dirty="0">
                 <a:solidFill>
                   <a:srgbClr val="12232B"/>
                 </a:solidFill>
@@ -9546,20 +9498,20 @@
               </a:rPr>
               <a:t>TOTAL REVENUE</a:t>
             </a:r>
-            <a:endParaRPr lang="en-US" sz="1300" dirty="0"/>
-          </a:p>
-        </p:txBody>
-      </p:sp>
-      <p:sp>
-        <p:nvSpPr>
-          <p:cNvPr id="38" name="Shape 36"/>
-          <p:cNvSpPr/>
-          <p:nvPr/>
-        </p:nvSpPr>
-        <p:spPr>
-          <a:xfrm>
-            <a:off x="3749040" y="4023360"/>
-            <a:ext cx="1874520" cy="640080"/>
+            <a:endParaRPr lang="en-US" sz="1200" dirty="0"/>
+          </a:p>
+        </p:txBody>
+      </p:sp>
+      <p:sp>
+        <p:nvSpPr>
+          <p:cNvPr id="39" name="Shape 37"/>
+          <p:cNvSpPr/>
+          <p:nvPr/>
+        </p:nvSpPr>
+        <p:spPr>
+          <a:xfrm>
+            <a:off x="3081528" y="4352544"/>
+            <a:ext cx="2011680" cy="640080"/>
           </a:xfrm>
           <a:prstGeom prst="rect">
             <a:avLst/>
@@ -9577,44 +9529,44 @@
       </p:sp>
       <p:sp>
         <p:nvSpPr>
-          <p:cNvPr id="39" name="Text 37"/>
-          <p:cNvSpPr/>
-          <p:nvPr/>
-        </p:nvSpPr>
-        <p:spPr>
-          <a:xfrm>
-            <a:off x="3840480" y="4078224"/>
-            <a:ext cx="1691640" cy="530352"/>
-          </a:xfrm>
-          <a:prstGeom prst="rect">
-            <a:avLst/>
-          </a:prstGeom>
-          <a:noFill/>
-          <a:ln/>
-        </p:spPr>
-        <p:txBody>
-          <a:bodyPr wrap="square" lIns="0" tIns="0" rIns="0" bIns="0" rtlCol="0" anchor="ctr">
-            <a:normAutofit/>
-          </a:bodyPr>
-          <a:lstStyle/>
-          <a:p>
-            <a:pPr algn="l" indent="0" marL="0">
-              <a:buNone/>
-            </a:pPr>
-            <a:endParaRPr lang="en-US" sz="1300" dirty="0"/>
-          </a:p>
-        </p:txBody>
-      </p:sp>
-      <p:sp>
-        <p:nvSpPr>
-          <p:cNvPr id="40" name="Shape 38"/>
-          <p:cNvSpPr/>
-          <p:nvPr/>
-        </p:nvSpPr>
-        <p:spPr>
-          <a:xfrm>
-            <a:off x="5623560" y="4023360"/>
-            <a:ext cx="1508760" cy="640080"/>
+          <p:cNvPr id="40" name="Text 38"/>
+          <p:cNvSpPr/>
+          <p:nvPr/>
+        </p:nvSpPr>
+        <p:spPr>
+          <a:xfrm>
+            <a:off x="3172968" y="4407408"/>
+            <a:ext cx="1828800" cy="530352"/>
+          </a:xfrm>
+          <a:prstGeom prst="rect">
+            <a:avLst/>
+          </a:prstGeom>
+          <a:noFill/>
+          <a:ln/>
+        </p:spPr>
+        <p:txBody>
+          <a:bodyPr wrap="square" lIns="0" tIns="0" rIns="0" bIns="0" rtlCol="0" anchor="ctr">
+            <a:normAutofit/>
+          </a:bodyPr>
+          <a:lstStyle/>
+          <a:p>
+            <a:pPr algn="l" indent="0" marL="0">
+              <a:buNone/>
+            </a:pPr>
+            <a:endParaRPr lang="en-US" sz="1200" dirty="0"/>
+          </a:p>
+        </p:txBody>
+      </p:sp>
+      <p:sp>
+        <p:nvSpPr>
+          <p:cNvPr id="41" name="Shape 39"/>
+          <p:cNvSpPr/>
+          <p:nvPr/>
+        </p:nvSpPr>
+        <p:spPr>
+          <a:xfrm>
+            <a:off x="5093208" y="4352544"/>
+            <a:ext cx="3154680" cy="640080"/>
           </a:xfrm>
           <a:prstGeom prst="rect">
             <a:avLst/>
@@ -9632,44 +9584,55 @@
       </p:sp>
       <p:sp>
         <p:nvSpPr>
-          <p:cNvPr id="41" name="Text 39"/>
-          <p:cNvSpPr/>
-          <p:nvPr/>
-        </p:nvSpPr>
-        <p:spPr>
-          <a:xfrm>
-            <a:off x="5715000" y="4078224"/>
-            <a:ext cx="1325880" cy="530352"/>
-          </a:xfrm>
-          <a:prstGeom prst="rect">
-            <a:avLst/>
-          </a:prstGeom>
-          <a:noFill/>
-          <a:ln/>
-        </p:spPr>
-        <p:txBody>
-          <a:bodyPr wrap="square" lIns="0" tIns="0" rIns="0" bIns="0" rtlCol="0" anchor="ctr">
-            <a:normAutofit/>
-          </a:bodyPr>
-          <a:lstStyle/>
-          <a:p>
-            <a:pPr algn="l" indent="0" marL="0">
-              <a:buNone/>
-            </a:pPr>
-            <a:endParaRPr lang="en-US" sz="1300" dirty="0"/>
-          </a:p>
-        </p:txBody>
-      </p:sp>
-      <p:sp>
-        <p:nvSpPr>
-          <p:cNvPr id="42" name="Shape 40"/>
-          <p:cNvSpPr/>
-          <p:nvPr/>
-        </p:nvSpPr>
-        <p:spPr>
-          <a:xfrm>
-            <a:off x="7132320" y="4023360"/>
-            <a:ext cx="2057400" cy="640080"/>
+          <p:cNvPr id="42" name="Text 40"/>
+          <p:cNvSpPr/>
+          <p:nvPr/>
+        </p:nvSpPr>
+        <p:spPr>
+          <a:xfrm>
+            <a:off x="5184648" y="4407408"/>
+            <a:ext cx="2971800" cy="530352"/>
+          </a:xfrm>
+          <a:prstGeom prst="rect">
+            <a:avLst/>
+          </a:prstGeom>
+          <a:noFill/>
+          <a:ln/>
+        </p:spPr>
+        <p:txBody>
+          <a:bodyPr wrap="square" lIns="0" tIns="0" rIns="0" bIns="0" rtlCol="0" anchor="ctr">
+            <a:normAutofit/>
+          </a:bodyPr>
+          <a:lstStyle/>
+          <a:p>
+            <a:pPr algn="l" indent="0" marL="0">
+              <a:buNone/>
+            </a:pPr>
+            <a:r>
+              <a:rPr lang="en-US" sz="1200" b="1" dirty="0">
+                <a:solidFill>
+                  <a:srgbClr val="12232B"/>
+                </a:solidFill>
+                <a:latin typeface="Arial" pitchFamily="34" charset="0"/>
+                <a:ea typeface="Arial" pitchFamily="34" charset="-122"/>
+                <a:cs typeface="Arial" pitchFamily="34" charset="-120"/>
+              </a:rPr>
+              <a:t>₦50,000 + ₦200,000 + ₦50,000</a:t>
+            </a:r>
+            <a:endParaRPr lang="en-US" sz="1200" dirty="0"/>
+          </a:p>
+        </p:txBody>
+      </p:sp>
+      <p:sp>
+        <p:nvSpPr>
+          <p:cNvPr id="43" name="Shape 41"/>
+          <p:cNvSpPr/>
+          <p:nvPr/>
+        </p:nvSpPr>
+        <p:spPr>
+          <a:xfrm>
+            <a:off x="8247888" y="4352544"/>
+            <a:ext cx="2240280" cy="640080"/>
           </a:xfrm>
           <a:prstGeom prst="rect">
             <a:avLst/>
@@ -9687,14 +9650,14 @@
       </p:sp>
       <p:sp>
         <p:nvSpPr>
-          <p:cNvPr id="43" name="Text 41"/>
-          <p:cNvSpPr/>
-          <p:nvPr/>
-        </p:nvSpPr>
-        <p:spPr>
-          <a:xfrm>
-            <a:off x="7223760" y="4078224"/>
-            <a:ext cx="1874520" cy="530352"/>
+          <p:cNvPr id="44" name="Text 42"/>
+          <p:cNvSpPr/>
+          <p:nvPr/>
+        </p:nvSpPr>
+        <p:spPr>
+          <a:xfrm>
+            <a:off x="8339328" y="4407408"/>
+            <a:ext cx="2057400" cy="530352"/>
           </a:xfrm>
           <a:prstGeom prst="rect">
             <a:avLst/>
@@ -9712,7 +9675,7 @@
               <a:buNone/>
             </a:pPr>
             <a:r>
-              <a:rPr lang="en-US" sz="1300" b="1" dirty="0">
+              <a:rPr lang="en-US" sz="1200" b="1" dirty="0">
                 <a:solidFill>
                   <a:srgbClr val="12232B"/>
                 </a:solidFill>
@@ -9722,176 +9685,24 @@
               </a:rPr>
               <a:t>300,000</a:t>
             </a:r>
-            <a:endParaRPr lang="en-US" sz="1300" dirty="0"/>
-          </a:p>
-        </p:txBody>
-      </p:sp>
-      <p:sp>
-        <p:nvSpPr>
-          <p:cNvPr id="44" name="Shape 42"/>
-          <p:cNvSpPr/>
-          <p:nvPr/>
-        </p:nvSpPr>
-        <p:spPr>
-          <a:xfrm>
-            <a:off x="8458200" y="1920240"/>
-            <a:ext cx="2788920" cy="2468880"/>
+            <a:endParaRPr lang="en-US" sz="1200" dirty="0"/>
+          </a:p>
+        </p:txBody>
+      </p:sp>
+      <p:sp>
+        <p:nvSpPr>
+          <p:cNvPr id="45" name="Shape 43"/>
+          <p:cNvSpPr/>
+          <p:nvPr/>
+        </p:nvSpPr>
+        <p:spPr>
+          <a:xfrm>
+            <a:off x="1965960" y="5230368"/>
+            <a:ext cx="8275320" cy="475488"/>
           </a:xfrm>
           <a:prstGeom prst="roundRect">
             <a:avLst>
-              <a:gd name="adj" fmla="val 2963"/>
-            </a:avLst>
-          </a:prstGeom>
-          <a:solidFill>
-            <a:srgbClr val="F4E7D4"/>
-          </a:solidFill>
-          <a:ln w="12700">
-            <a:solidFill>
-              <a:srgbClr val="F4E7D4">
-                <a:alpha val="0"/>
-              </a:srgbClr>
-            </a:solidFill>
-            <a:prstDash val="solid"/>
-          </a:ln>
-        </p:spPr>
-      </p:sp>
-      <p:sp>
-        <p:nvSpPr>
-          <p:cNvPr id="45" name="Text 43"/>
-          <p:cNvSpPr/>
-          <p:nvPr/>
-        </p:nvSpPr>
-        <p:spPr>
-          <a:xfrm>
-            <a:off x="8759952" y="2267712"/>
-            <a:ext cx="2176272" cy="228600"/>
-          </a:xfrm>
-          <a:prstGeom prst="rect">
-            <a:avLst/>
-          </a:prstGeom>
-          <a:noFill/>
-          <a:ln/>
-        </p:spPr>
-        <p:txBody>
-          <a:bodyPr wrap="square" lIns="0" tIns="0" rIns="0" bIns="0" rtlCol="0" anchor="ctr">
-            <a:normAutofit/>
-          </a:bodyPr>
-          <a:lstStyle/>
-          <a:p>
-            <a:pPr algn="l" indent="0" marL="0">
-              <a:buNone/>
-            </a:pPr>
-            <a:r>
-              <a:rPr lang="en-US" sz="1100" b="1" dirty="0">
-                <a:solidFill>
-                  <a:srgbClr val="2E7D73"/>
-                </a:solidFill>
-                <a:latin typeface="Arial" pitchFamily="34" charset="0"/>
-                <a:ea typeface="Arial" pitchFamily="34" charset="-122"/>
-                <a:cs typeface="Arial" pitchFamily="34" charset="-120"/>
-              </a:rPr>
-              <a:t>TOTAL REVENUE</a:t>
-            </a:r>
-            <a:endParaRPr lang="en-US" sz="1100" dirty="0"/>
-          </a:p>
-        </p:txBody>
-      </p:sp>
-      <p:sp>
-        <p:nvSpPr>
-          <p:cNvPr id="46" name="Text 44"/>
-          <p:cNvSpPr/>
-          <p:nvPr/>
-        </p:nvSpPr>
-        <p:spPr>
-          <a:xfrm>
-            <a:off x="8759952" y="2651760"/>
-            <a:ext cx="2176272" cy="475488"/>
-          </a:xfrm>
-          <a:prstGeom prst="rect">
-            <a:avLst/>
-          </a:prstGeom>
-          <a:noFill/>
-          <a:ln/>
-        </p:spPr>
-        <p:txBody>
-          <a:bodyPr wrap="square" lIns="0" tIns="0" rIns="0" bIns="0" rtlCol="0" anchor="ctr">
-            <a:normAutofit/>
-          </a:bodyPr>
-          <a:lstStyle/>
-          <a:p>
-            <a:pPr algn="l" indent="0" marL="0">
-              <a:buNone/>
-            </a:pPr>
-            <a:r>
-              <a:rPr lang="en-US" sz="2600" b="1" dirty="0">
-                <a:solidFill>
-                  <a:srgbClr val="12232B"/>
-                </a:solidFill>
-                <a:latin typeface="Arial" pitchFamily="34" charset="0"/>
-                <a:ea typeface="Arial" pitchFamily="34" charset="-122"/>
-                <a:cs typeface="Arial" pitchFamily="34" charset="-120"/>
-              </a:rPr>
-              <a:t>₦300,000</a:t>
-            </a:r>
-            <a:endParaRPr lang="en-US" sz="2600" dirty="0"/>
-          </a:p>
-        </p:txBody>
-      </p:sp>
-      <p:sp>
-        <p:nvSpPr>
-          <p:cNvPr id="47" name="Text 45"/>
-          <p:cNvSpPr/>
-          <p:nvPr/>
-        </p:nvSpPr>
-        <p:spPr>
-          <a:xfrm>
-            <a:off x="8759952" y="3429000"/>
-            <a:ext cx="2157984" cy="566928"/>
-          </a:xfrm>
-          <a:prstGeom prst="rect">
-            <a:avLst/>
-          </a:prstGeom>
-          <a:noFill/>
-          <a:ln/>
-        </p:spPr>
-        <p:txBody>
-          <a:bodyPr wrap="square" lIns="0" tIns="0" rIns="0" bIns="0" rtlCol="0" anchor="ctr">
-            <a:normAutofit/>
-          </a:bodyPr>
-          <a:lstStyle/>
-          <a:p>
-            <a:pPr algn="l" indent="0" marL="0">
-              <a:buNone/>
-            </a:pPr>
-            <a:r>
-              <a:rPr lang="en-US" sz="1100" dirty="0">
-                <a:solidFill>
-                  <a:srgbClr val="68767C"/>
-                </a:solidFill>
-                <a:latin typeface="Arial" pitchFamily="34" charset="0"/>
-                <a:ea typeface="Arial" pitchFamily="34" charset="-122"/>
-                <a:cs typeface="Arial" pitchFamily="34" charset="-120"/>
-              </a:rPr>
-              <a:t>This is a projection unless the team has verified records of actual revenue.</a:t>
-            </a:r>
-            <a:endParaRPr lang="en-US" sz="1100" dirty="0"/>
-          </a:p>
-        </p:txBody>
-      </p:sp>
-      <p:sp>
-        <p:nvSpPr>
-          <p:cNvPr id="48" name="Shape 46"/>
-          <p:cNvSpPr/>
-          <p:nvPr/>
-        </p:nvSpPr>
-        <p:spPr>
-          <a:xfrm>
-            <a:off x="1143000" y="5120640"/>
-            <a:ext cx="9875520" cy="502920"/>
-          </a:xfrm>
-          <a:prstGeom prst="roundRect">
-            <a:avLst>
-              <a:gd name="adj" fmla="val 14545"/>
+              <a:gd name="adj" fmla="val 15385"/>
             </a:avLst>
           </a:prstGeom>
           <a:solidFill>
@@ -9909,48 +9720,118 @@
       </p:sp>
       <p:sp>
         <p:nvSpPr>
+          <p:cNvPr id="46" name="Text 44"/>
+          <p:cNvSpPr/>
+          <p:nvPr/>
+        </p:nvSpPr>
+        <p:spPr>
+          <a:xfrm>
+            <a:off x="2176272" y="5349240"/>
+            <a:ext cx="7845552" cy="201168"/>
+          </a:xfrm>
+          <a:prstGeom prst="rect">
+            <a:avLst/>
+          </a:prstGeom>
+          <a:noFill/>
+          <a:ln/>
+        </p:spPr>
+        <p:txBody>
+          <a:bodyPr wrap="square" lIns="0" tIns="0" rIns="0" bIns="0" rtlCol="0" anchor="ctr">
+            <a:normAutofit/>
+          </a:bodyPr>
+          <a:lstStyle/>
+          <a:p>
+            <a:pPr algn="ctr" indent="0" marL="0">
+              <a:buNone/>
+            </a:pPr>
+            <a:r>
+              <a:rPr lang="en-US" sz="1400" b="1" dirty="0">
+                <a:solidFill>
+                  <a:srgbClr val="FFFFFF"/>
+                </a:solidFill>
+                <a:latin typeface="Arial" pitchFamily="34" charset="0"/>
+                <a:ea typeface="Arial" pitchFamily="34" charset="-122"/>
+                <a:cs typeface="Arial" pitchFamily="34" charset="-120"/>
+              </a:rPr>
+              <a:t>PROJECTED TOTAL REVENUE:  ₦300,000</a:t>
+            </a:r>
+            <a:endParaRPr lang="en-US" sz="1400" dirty="0"/>
+          </a:p>
+        </p:txBody>
+      </p:sp>
+      <p:sp>
+        <p:nvSpPr>
+          <p:cNvPr id="47" name="Shape 45"/>
+          <p:cNvSpPr/>
+          <p:nvPr/>
+        </p:nvSpPr>
+        <p:spPr>
+          <a:xfrm>
+            <a:off x="3474720" y="5870448"/>
+            <a:ext cx="4041648" cy="301752"/>
+          </a:xfrm>
+          <a:prstGeom prst="roundRect">
+            <a:avLst>
+              <a:gd name="adj" fmla="val 24242"/>
+            </a:avLst>
+          </a:prstGeom>
+          <a:solidFill>
+            <a:srgbClr val="D9776A"/>
+          </a:solidFill>
+          <a:ln w="12700">
+            <a:solidFill>
+              <a:srgbClr val="D9776A">
+                <a:alpha val="0"/>
+              </a:srgbClr>
+            </a:solidFill>
+            <a:prstDash val="solid"/>
+          </a:ln>
+        </p:spPr>
+      </p:sp>
+      <p:sp>
+        <p:nvSpPr>
+          <p:cNvPr id="48" name="Text 46"/>
+          <p:cNvSpPr/>
+          <p:nvPr/>
+        </p:nvSpPr>
+        <p:spPr>
+          <a:xfrm>
+            <a:off x="3547872" y="5879592"/>
+            <a:ext cx="3895344" cy="274320"/>
+          </a:xfrm>
+          <a:prstGeom prst="rect">
+            <a:avLst/>
+          </a:prstGeom>
+          <a:noFill/>
+          <a:ln/>
+        </p:spPr>
+        <p:txBody>
+          <a:bodyPr wrap="square" lIns="0" tIns="0" rIns="0" bIns="0" rtlCol="0" anchor="ctr">
+            <a:normAutofit/>
+          </a:bodyPr>
+          <a:lstStyle/>
+          <a:p>
+            <a:pPr algn="ctr" indent="0" marL="0">
+              <a:buNone/>
+            </a:pPr>
+            <a:r>
+              <a:rPr lang="en-US" sz="900" b="1" dirty="0">
+                <a:solidFill>
+                  <a:srgbClr val="FFFFFF"/>
+                </a:solidFill>
+                <a:latin typeface="Arial" pitchFamily="34" charset="0"/>
+                <a:ea typeface="Arial" pitchFamily="34" charset="-122"/>
+                <a:cs typeface="Arial" pitchFamily="34" charset="-120"/>
+              </a:rPr>
+              <a:t>PROJECTION — VERIFY FIGURES BEFORE SUBMISSION</a:t>
+            </a:r>
+            <a:endParaRPr lang="en-US" sz="900" dirty="0"/>
+          </a:p>
+        </p:txBody>
+      </p:sp>
+      <p:sp>
+        <p:nvSpPr>
           <p:cNvPr id="49" name="Text 47"/>
-          <p:cNvSpPr/>
-          <p:nvPr/>
-        </p:nvSpPr>
-        <p:spPr>
-          <a:xfrm>
-            <a:off x="1417320" y="5266944"/>
-            <a:ext cx="9326880" cy="201168"/>
-          </a:xfrm>
-          <a:prstGeom prst="rect">
-            <a:avLst/>
-          </a:prstGeom>
-          <a:noFill/>
-          <a:ln/>
-        </p:spPr>
-        <p:txBody>
-          <a:bodyPr wrap="square" lIns="0" tIns="0" rIns="0" bIns="0" rtlCol="0" anchor="ctr">
-            <a:normAutofit/>
-          </a:bodyPr>
-          <a:lstStyle/>
-          <a:p>
-            <a:pPr algn="ctr" indent="0" marL="0">
-              <a:buNone/>
-            </a:pPr>
-            <a:r>
-              <a:rPr lang="en-US" sz="1200" b="1" dirty="0">
-                <a:solidFill>
-                  <a:srgbClr val="FFFFFF"/>
-                </a:solidFill>
-                <a:latin typeface="Arial" pitchFamily="34" charset="0"/>
-                <a:ea typeface="Arial" pitchFamily="34" charset="-122"/>
-                <a:cs typeface="Arial" pitchFamily="34" charset="-120"/>
-              </a:rPr>
-              <a:t>Revenue sources shown: shares + sponsorship + sales of confectioneries.</a:t>
-            </a:r>
-            <a:endParaRPr lang="en-US" sz="1200" dirty="0"/>
-          </a:p>
-        </p:txBody>
-      </p:sp>
-      <p:sp>
-        <p:nvSpPr>
-          <p:cNvPr id="50" name="Text 48"/>
           <p:cNvSpPr/>
           <p:nvPr/>
         </p:nvSpPr>

</xml_diff>